<commit_message>
Add complete benchmark slides with validated charts
Slide 18 is the comprehensive benchmark: five stat tiles (100% micro
precision, 0 invariant leaks, 0 false alarms, 15.9 ms local p50, 10/10
red team), a grouped per-class detection table with the documented gaps
in plain sight, the fortress trade-off, and the measured latency
waterfall chart. Slide 19 carries the full 18-class recall chart with
annotated gaps, the blur-attack comparison, the executable red team
results and the suite footprint. Charts are hand-built SVG following
the dataviz method (single-hue marks, direct labels, flat baseline with
rounded data ends, recessive grid, palette contrast validated) and are
rendered to PNG by the same headless pipeline as the rest of the deck.
Fresh bench run: 15.9 ms summed single-frame p50 this pass.
</commit_message>
<xml_diff>
--- a/docs/Kavach-SIH2026-Deck.pptx
+++ b/docs/Kavach-SIH2026-Deck.pptx
@@ -5630,7 +5630,7 @@
                 <a:ea typeface="Arial" pitchFamily="34" charset="-122"/>
                 <a:cs typeface="Arial" pitchFamily="34" charset="-120"/>
               </a:rPr>
-              <a:t>MEASURED, NOT PROMISED</a:t>
+              <a:t>THE BENCHMARK</a:t>
             </a:r>
             <a:endParaRPr lang="en-US" sz="1100" dirty="0"/>
           </a:p>
@@ -5669,9 +5669,563 @@
                 <a:ea typeface="Arial" pitchFamily="34" charset="-122"/>
                 <a:cs typeface="Arial" pitchFamily="34" charset="-120"/>
               </a:rPr>
-              <a:t>RedactBench-Web: our benchmark, our numbers, as CI gates</a:t>
+              <a:t>Every claim measured, every number a CI gate</a:t>
             </a:r>
             <a:endParaRPr lang="en-US" sz="2600" dirty="0"/>
+          </a:p>
+        </p:txBody>
+      </p:sp>
+      <p:sp>
+        <p:nvSpPr>
+          <p:cNvPr id="4" name="Shape 2"/>
+          <p:cNvSpPr/>
+          <p:nvPr/>
+        </p:nvSpPr>
+        <p:spPr>
+          <a:xfrm>
+            <a:off x="502920" y="1207008"/>
+            <a:ext cx="2121408" cy="914400"/>
+          </a:xfrm>
+          <a:prstGeom prst="rect">
+            <a:avLst/>
+          </a:prstGeom>
+          <a:solidFill>
+            <a:srgbClr val="EEF3F8"/>
+          </a:solidFill>
+          <a:ln w="9525">
+            <a:solidFill>
+              <a:srgbClr val="D6DAE0"/>
+            </a:solidFill>
+            <a:prstDash val="solid"/>
+          </a:ln>
+        </p:spPr>
+      </p:sp>
+      <p:sp>
+        <p:nvSpPr>
+          <p:cNvPr id="5" name="Text 3"/>
+          <p:cNvSpPr/>
+          <p:nvPr/>
+        </p:nvSpPr>
+        <p:spPr>
+          <a:xfrm>
+            <a:off x="502920" y="1280160"/>
+            <a:ext cx="2121408" cy="457200"/>
+          </a:xfrm>
+          <a:prstGeom prst="rect">
+            <a:avLst/>
+          </a:prstGeom>
+          <a:noFill/>
+          <a:ln/>
+        </p:spPr>
+        <p:txBody>
+          <a:bodyPr wrap="square" rtlCol="0" anchor="ctr"/>
+          <a:lstStyle/>
+          <a:p>
+            <a:pPr algn="ctr" indent="0" marL="0">
+              <a:buNone/>
+            </a:pPr>
+            <a:r>
+              <a:rPr lang="en-US" sz="2100" b="1" dirty="0">
+                <a:solidFill>
+                  <a:srgbClr val="3D5A3D"/>
+                </a:solidFill>
+                <a:latin typeface="Arial" pitchFamily="34" charset="0"/>
+                <a:ea typeface="Arial" pitchFamily="34" charset="-122"/>
+                <a:cs typeface="Arial" pitchFamily="34" charset="-120"/>
+              </a:rPr>
+              <a:t>100%</a:t>
+            </a:r>
+            <a:endParaRPr lang="en-US" sz="2100" dirty="0"/>
+          </a:p>
+        </p:txBody>
+      </p:sp>
+      <p:sp>
+        <p:nvSpPr>
+          <p:cNvPr id="6" name="Text 4"/>
+          <p:cNvSpPr/>
+          <p:nvPr/>
+        </p:nvSpPr>
+        <p:spPr>
+          <a:xfrm>
+            <a:off x="557784" y="1700784"/>
+            <a:ext cx="2011680" cy="384048"/>
+          </a:xfrm>
+          <a:prstGeom prst="rect">
+            <a:avLst/>
+          </a:prstGeom>
+          <a:noFill/>
+          <a:ln/>
+        </p:spPr>
+        <p:txBody>
+          <a:bodyPr wrap="square" rtlCol="0" anchor="ctr"/>
+          <a:lstStyle/>
+          <a:p>
+            <a:pPr algn="ctr" indent="0" marL="0">
+              <a:buNone/>
+            </a:pPr>
+            <a:r>
+              <a:rPr lang="en-US" sz="880" dirty="0">
+                <a:solidFill>
+                  <a:srgbClr val="5A6470"/>
+                </a:solidFill>
+                <a:latin typeface="Arial" pitchFamily="34" charset="0"/>
+                <a:ea typeface="Arial" pitchFamily="34" charset="-122"/>
+                <a:cs typeface="Arial" pitchFamily="34" charset="-120"/>
+              </a:rPr>
+              <a:t>micro precision, Shield</a:t>
+            </a:r>
+            <a:endParaRPr lang="en-US" sz="880" dirty="0"/>
+          </a:p>
+        </p:txBody>
+      </p:sp>
+      <p:sp>
+        <p:nvSpPr>
+          <p:cNvPr id="7" name="Shape 5"/>
+          <p:cNvSpPr/>
+          <p:nvPr/>
+        </p:nvSpPr>
+        <p:spPr>
+          <a:xfrm>
+            <a:off x="2761488" y="1207008"/>
+            <a:ext cx="2121408" cy="914400"/>
+          </a:xfrm>
+          <a:prstGeom prst="rect">
+            <a:avLst/>
+          </a:prstGeom>
+          <a:solidFill>
+            <a:srgbClr val="EEF3F8"/>
+          </a:solidFill>
+          <a:ln w="9525">
+            <a:solidFill>
+              <a:srgbClr val="D6DAE0"/>
+            </a:solidFill>
+            <a:prstDash val="solid"/>
+          </a:ln>
+        </p:spPr>
+      </p:sp>
+      <p:sp>
+        <p:nvSpPr>
+          <p:cNvPr id="8" name="Text 6"/>
+          <p:cNvSpPr/>
+          <p:nvPr/>
+        </p:nvSpPr>
+        <p:spPr>
+          <a:xfrm>
+            <a:off x="2761488" y="1280160"/>
+            <a:ext cx="2121408" cy="457200"/>
+          </a:xfrm>
+          <a:prstGeom prst="rect">
+            <a:avLst/>
+          </a:prstGeom>
+          <a:noFill/>
+          <a:ln/>
+        </p:spPr>
+        <p:txBody>
+          <a:bodyPr wrap="square" rtlCol="0" anchor="ctr"/>
+          <a:lstStyle/>
+          <a:p>
+            <a:pPr algn="ctr" indent="0" marL="0">
+              <a:buNone/>
+            </a:pPr>
+            <a:r>
+              <a:rPr lang="en-US" sz="2100" b="1" dirty="0">
+                <a:solidFill>
+                  <a:srgbClr val="3D5A3D"/>
+                </a:solidFill>
+                <a:latin typeface="Arial" pitchFamily="34" charset="0"/>
+                <a:ea typeface="Arial" pitchFamily="34" charset="-122"/>
+                <a:cs typeface="Arial" pitchFamily="34" charset="-120"/>
+              </a:rPr>
+              <a:t>0</a:t>
+            </a:r>
+            <a:endParaRPr lang="en-US" sz="2100" dirty="0"/>
+          </a:p>
+        </p:txBody>
+      </p:sp>
+      <p:sp>
+        <p:nvSpPr>
+          <p:cNvPr id="9" name="Text 7"/>
+          <p:cNvSpPr/>
+          <p:nvPr/>
+        </p:nvSpPr>
+        <p:spPr>
+          <a:xfrm>
+            <a:off x="2816352" y="1700784"/>
+            <a:ext cx="2011680" cy="384048"/>
+          </a:xfrm>
+          <a:prstGeom prst="rect">
+            <a:avLst/>
+          </a:prstGeom>
+          <a:noFill/>
+          <a:ln/>
+        </p:spPr>
+        <p:txBody>
+          <a:bodyPr wrap="square" rtlCol="0" anchor="ctr"/>
+          <a:lstStyle/>
+          <a:p>
+            <a:pPr algn="ctr" indent="0" marL="0">
+              <a:buNone/>
+            </a:pPr>
+            <a:r>
+              <a:rPr lang="en-US" sz="880" dirty="0">
+                <a:solidFill>
+                  <a:srgbClr val="5A6470"/>
+                </a:solidFill>
+                <a:latin typeface="Arial" pitchFamily="34" charset="0"/>
+                <a:ea typeface="Arial" pitchFamily="34" charset="-122"/>
+                <a:cs typeface="Arial" pitchFamily="34" charset="-120"/>
+              </a:rPr>
+              <a:t>invariant-class leaks</a:t>
+            </a:r>
+            <a:endParaRPr lang="en-US" sz="880" dirty="0"/>
+          </a:p>
+        </p:txBody>
+      </p:sp>
+      <p:sp>
+        <p:nvSpPr>
+          <p:cNvPr id="10" name="Shape 8"/>
+          <p:cNvSpPr/>
+          <p:nvPr/>
+        </p:nvSpPr>
+        <p:spPr>
+          <a:xfrm>
+            <a:off x="5020056" y="1207008"/>
+            <a:ext cx="2121408" cy="914400"/>
+          </a:xfrm>
+          <a:prstGeom prst="rect">
+            <a:avLst/>
+          </a:prstGeom>
+          <a:solidFill>
+            <a:srgbClr val="EEF3F8"/>
+          </a:solidFill>
+          <a:ln w="9525">
+            <a:solidFill>
+              <a:srgbClr val="D6DAE0"/>
+            </a:solidFill>
+            <a:prstDash val="solid"/>
+          </a:ln>
+        </p:spPr>
+      </p:sp>
+      <p:sp>
+        <p:nvSpPr>
+          <p:cNvPr id="11" name="Text 9"/>
+          <p:cNvSpPr/>
+          <p:nvPr/>
+        </p:nvSpPr>
+        <p:spPr>
+          <a:xfrm>
+            <a:off x="5020056" y="1280160"/>
+            <a:ext cx="2121408" cy="457200"/>
+          </a:xfrm>
+          <a:prstGeom prst="rect">
+            <a:avLst/>
+          </a:prstGeom>
+          <a:noFill/>
+          <a:ln/>
+        </p:spPr>
+        <p:txBody>
+          <a:bodyPr wrap="square" rtlCol="0" anchor="ctr"/>
+          <a:lstStyle/>
+          <a:p>
+            <a:pPr algn="ctr" indent="0" marL="0">
+              <a:buNone/>
+            </a:pPr>
+            <a:r>
+              <a:rPr lang="en-US" sz="2100" b="1" dirty="0">
+                <a:solidFill>
+                  <a:srgbClr val="3D5A3D"/>
+                </a:solidFill>
+                <a:latin typeface="Arial" pitchFamily="34" charset="0"/>
+                <a:ea typeface="Arial" pitchFamily="34" charset="-122"/>
+                <a:cs typeface="Arial" pitchFamily="34" charset="-120"/>
+              </a:rPr>
+              <a:t>0</a:t>
+            </a:r>
+            <a:endParaRPr lang="en-US" sz="2100" dirty="0"/>
+          </a:p>
+        </p:txBody>
+      </p:sp>
+      <p:sp>
+        <p:nvSpPr>
+          <p:cNvPr id="12" name="Text 10"/>
+          <p:cNvSpPr/>
+          <p:nvPr/>
+        </p:nvSpPr>
+        <p:spPr>
+          <a:xfrm>
+            <a:off x="5074920" y="1700784"/>
+            <a:ext cx="2011680" cy="384048"/>
+          </a:xfrm>
+          <a:prstGeom prst="rect">
+            <a:avLst/>
+          </a:prstGeom>
+          <a:noFill/>
+          <a:ln/>
+        </p:spPr>
+        <p:txBody>
+          <a:bodyPr wrap="square" rtlCol="0" anchor="ctr"/>
+          <a:lstStyle/>
+          <a:p>
+            <a:pPr algn="ctr" indent="0" marL="0">
+              <a:buNone/>
+            </a:pPr>
+            <a:r>
+              <a:rPr lang="en-US" sz="880" dirty="0">
+                <a:solidFill>
+                  <a:srgbClr val="5A6470"/>
+                </a:solidFill>
+                <a:latin typeface="Arial" pitchFamily="34" charset="0"/>
+                <a:ea typeface="Arial" pitchFamily="34" charset="-122"/>
+                <a:cs typeface="Arial" pitchFamily="34" charset="-120"/>
+              </a:rPr>
+              <a:t>false alarms on negatives</a:t>
+            </a:r>
+            <a:endParaRPr lang="en-US" sz="880" dirty="0"/>
+          </a:p>
+        </p:txBody>
+      </p:sp>
+      <p:sp>
+        <p:nvSpPr>
+          <p:cNvPr id="13" name="Shape 11"/>
+          <p:cNvSpPr/>
+          <p:nvPr/>
+        </p:nvSpPr>
+        <p:spPr>
+          <a:xfrm>
+            <a:off x="7278624" y="1207008"/>
+            <a:ext cx="2121408" cy="914400"/>
+          </a:xfrm>
+          <a:prstGeom prst="rect">
+            <a:avLst/>
+          </a:prstGeom>
+          <a:solidFill>
+            <a:srgbClr val="EEF3F8"/>
+          </a:solidFill>
+          <a:ln w="9525">
+            <a:solidFill>
+              <a:srgbClr val="D6DAE0"/>
+            </a:solidFill>
+            <a:prstDash val="solid"/>
+          </a:ln>
+        </p:spPr>
+      </p:sp>
+      <p:sp>
+        <p:nvSpPr>
+          <p:cNvPr id="14" name="Text 12"/>
+          <p:cNvSpPr/>
+          <p:nvPr/>
+        </p:nvSpPr>
+        <p:spPr>
+          <a:xfrm>
+            <a:off x="7278624" y="1280160"/>
+            <a:ext cx="2121408" cy="457200"/>
+          </a:xfrm>
+          <a:prstGeom prst="rect">
+            <a:avLst/>
+          </a:prstGeom>
+          <a:noFill/>
+          <a:ln/>
+        </p:spPr>
+        <p:txBody>
+          <a:bodyPr wrap="square" rtlCol="0" anchor="ctr"/>
+          <a:lstStyle/>
+          <a:p>
+            <a:pPr algn="ctr" indent="0" marL="0">
+              <a:buNone/>
+            </a:pPr>
+            <a:r>
+              <a:rPr lang="en-US" sz="2100" b="1" dirty="0">
+                <a:solidFill>
+                  <a:srgbClr val="1F4E79"/>
+                </a:solidFill>
+                <a:latin typeface="Arial" pitchFamily="34" charset="0"/>
+                <a:ea typeface="Arial" pitchFamily="34" charset="-122"/>
+                <a:cs typeface="Arial" pitchFamily="34" charset="-120"/>
+              </a:rPr>
+              <a:t>15.9 ms</a:t>
+            </a:r>
+            <a:endParaRPr lang="en-US" sz="2100" dirty="0"/>
+          </a:p>
+        </p:txBody>
+      </p:sp>
+      <p:sp>
+        <p:nvSpPr>
+          <p:cNvPr id="15" name="Text 13"/>
+          <p:cNvSpPr/>
+          <p:nvPr/>
+        </p:nvSpPr>
+        <p:spPr>
+          <a:xfrm>
+            <a:off x="7333488" y="1700784"/>
+            <a:ext cx="2011680" cy="384048"/>
+          </a:xfrm>
+          <a:prstGeom prst="rect">
+            <a:avLst/>
+          </a:prstGeom>
+          <a:noFill/>
+          <a:ln/>
+        </p:spPr>
+        <p:txBody>
+          <a:bodyPr wrap="square" rtlCol="0" anchor="ctr"/>
+          <a:lstStyle/>
+          <a:p>
+            <a:pPr algn="ctr" indent="0" marL="0">
+              <a:buNone/>
+            </a:pPr>
+            <a:r>
+              <a:rPr lang="en-US" sz="880" dirty="0">
+                <a:solidFill>
+                  <a:srgbClr val="5A6470"/>
+                </a:solidFill>
+                <a:latin typeface="Arial" pitchFamily="34" charset="0"/>
+                <a:ea typeface="Arial" pitchFamily="34" charset="-122"/>
+                <a:cs typeface="Arial" pitchFamily="34" charset="-120"/>
+              </a:rPr>
+              <a:t>local pipeline p50 (175 ms budget)</a:t>
+            </a:r>
+            <a:endParaRPr lang="en-US" sz="880" dirty="0"/>
+          </a:p>
+        </p:txBody>
+      </p:sp>
+      <p:sp>
+        <p:nvSpPr>
+          <p:cNvPr id="16" name="Shape 14"/>
+          <p:cNvSpPr/>
+          <p:nvPr/>
+        </p:nvSpPr>
+        <p:spPr>
+          <a:xfrm>
+            <a:off x="9537192" y="1207008"/>
+            <a:ext cx="2121408" cy="914400"/>
+          </a:xfrm>
+          <a:prstGeom prst="rect">
+            <a:avLst/>
+          </a:prstGeom>
+          <a:solidFill>
+            <a:srgbClr val="EEF3F8"/>
+          </a:solidFill>
+          <a:ln w="9525">
+            <a:solidFill>
+              <a:srgbClr val="D6DAE0"/>
+            </a:solidFill>
+            <a:prstDash val="solid"/>
+          </a:ln>
+        </p:spPr>
+      </p:sp>
+      <p:sp>
+        <p:nvSpPr>
+          <p:cNvPr id="17" name="Text 15"/>
+          <p:cNvSpPr/>
+          <p:nvPr/>
+        </p:nvSpPr>
+        <p:spPr>
+          <a:xfrm>
+            <a:off x="9537192" y="1280160"/>
+            <a:ext cx="2121408" cy="457200"/>
+          </a:xfrm>
+          <a:prstGeom prst="rect">
+            <a:avLst/>
+          </a:prstGeom>
+          <a:noFill/>
+          <a:ln/>
+        </p:spPr>
+        <p:txBody>
+          <a:bodyPr wrap="square" rtlCol="0" anchor="ctr"/>
+          <a:lstStyle/>
+          <a:p>
+            <a:pPr algn="ctr" indent="0" marL="0">
+              <a:buNone/>
+            </a:pPr>
+            <a:r>
+              <a:rPr lang="en-US" sz="2100" b="1" dirty="0">
+                <a:solidFill>
+                  <a:srgbClr val="1F4E79"/>
+                </a:solidFill>
+                <a:latin typeface="Arial" pitchFamily="34" charset="0"/>
+                <a:ea typeface="Arial" pitchFamily="34" charset="-122"/>
+                <a:cs typeface="Arial" pitchFamily="34" charset="-120"/>
+              </a:rPr>
+              <a:t>10 / 10</a:t>
+            </a:r>
+            <a:endParaRPr lang="en-US" sz="2100" dirty="0"/>
+          </a:p>
+        </p:txBody>
+      </p:sp>
+      <p:sp>
+        <p:nvSpPr>
+          <p:cNvPr id="18" name="Text 16"/>
+          <p:cNvSpPr/>
+          <p:nvPr/>
+        </p:nvSpPr>
+        <p:spPr>
+          <a:xfrm>
+            <a:off x="9592056" y="1700784"/>
+            <a:ext cx="2011680" cy="384048"/>
+          </a:xfrm>
+          <a:prstGeom prst="rect">
+            <a:avLst/>
+          </a:prstGeom>
+          <a:noFill/>
+          <a:ln/>
+        </p:spPr>
+        <p:txBody>
+          <a:bodyPr wrap="square" rtlCol="0" anchor="ctr"/>
+          <a:lstStyle/>
+          <a:p>
+            <a:pPr algn="ctr" indent="0" marL="0">
+              <a:buNone/>
+            </a:pPr>
+            <a:r>
+              <a:rPr lang="en-US" sz="880" dirty="0">
+                <a:solidFill>
+                  <a:srgbClr val="5A6470"/>
+                </a:solidFill>
+                <a:latin typeface="Arial" pitchFamily="34" charset="0"/>
+                <a:ea typeface="Arial" pitchFamily="34" charset="-122"/>
+                <a:cs typeface="Arial" pitchFamily="34" charset="-120"/>
+              </a:rPr>
+              <a:t>red team defences hold</a:t>
+            </a:r>
+            <a:endParaRPr lang="en-US" sz="880" dirty="0"/>
+          </a:p>
+        </p:txBody>
+      </p:sp>
+      <p:sp>
+        <p:nvSpPr>
+          <p:cNvPr id="19" name="Text 17"/>
+          <p:cNvSpPr/>
+          <p:nvPr/>
+        </p:nvSpPr>
+        <p:spPr>
+          <a:xfrm>
+            <a:off x="502920" y="2331720"/>
+            <a:ext cx="5760720" cy="274320"/>
+          </a:xfrm>
+          <a:prstGeom prst="rect">
+            <a:avLst/>
+          </a:prstGeom>
+          <a:noFill/>
+          <a:ln/>
+        </p:spPr>
+        <p:txBody>
+          <a:bodyPr wrap="square" rtlCol="0" anchor="ctr"/>
+          <a:lstStyle/>
+          <a:p>
+            <a:pPr indent="0" marL="0">
+              <a:buNone/>
+            </a:pPr>
+            <a:r>
+              <a:rPr lang="en-US" sz="1200" b="1" dirty="0">
+                <a:solidFill>
+                  <a:srgbClr val="1F4E79"/>
+                </a:solidFill>
+                <a:latin typeface="Arial" pitchFamily="34" charset="0"/>
+                <a:ea typeface="Arial" pitchFamily="34" charset="-122"/>
+                <a:cs typeface="Arial" pitchFamily="34" charset="-120"/>
+              </a:rPr>
+              <a:t>Detection quality (RedactBench-Web, Shield tier)</a:t>
+            </a:r>
+            <a:endParaRPr lang="en-US" sz="1200" dirty="0"/>
           </a:p>
         </p:txBody>
       </p:sp>
@@ -5690,21 +6244,20 @@
           </p:nvPr>
         </p:nvGraphicFramePr>
         <p:xfrm>
-          <a:off x="502920" y="1371600"/>
-          <a:ext cx="11155680" cy="914400"/>
+          <a:off x="502920" y="2651760"/>
+          <a:ext cx="5760720" cy="914400"/>
         </p:xfrm>
         <a:graphic>
           <a:graphicData uri="http://schemas.openxmlformats.org/drawingml/2006/table">
             <a:tbl>
               <a:tblPr/>
               <a:tblGrid>
-                <a:gridCol w="2231136"/>
-                <a:gridCol w="2231136"/>
-                <a:gridCol w="2231136"/>
-                <a:gridCol w="2231136"/>
-                <a:gridCol w="2231136"/>
+                <a:gridCol w="3291840"/>
+                <a:gridCol w="731520"/>
+                <a:gridCol w="868680"/>
+                <a:gridCol w="868680"/>
               </a:tblGrid>
-              <a:tr h="502920">
+              <a:tr h="365760">
                 <a:tc>
                   <a:txBody>
                     <a:bodyPr/>
@@ -5722,7 +6275,7 @@
                           <a:ea typeface="Arial" pitchFamily="34" charset="-122"/>
                           <a:cs typeface="Arial" pitchFamily="34" charset="-120"/>
                         </a:rPr>
-                        <a:t>Mode</a:t>
+                        <a:t>Class group</a:t>
                       </a:r>
                       <a:endParaRPr lang="en-US" sz="1100" dirty="0">
                         <a:latin typeface="Arial" charset="0"/>
@@ -5790,7 +6343,7 @@
                           <a:ea typeface="Arial" pitchFamily="34" charset="-122"/>
                           <a:cs typeface="Arial" pitchFamily="34" charset="-120"/>
                         </a:rPr>
-                        <a:t>Micro precision</a:t>
+                        <a:t>Support</a:t>
                       </a:r>
                       <a:endParaRPr lang="en-US" sz="1100" dirty="0">
                         <a:latin typeface="Arial" charset="0"/>
@@ -5858,7 +6411,7 @@
                           <a:ea typeface="Arial" pitchFamily="34" charset="-122"/>
                           <a:cs typeface="Arial" pitchFamily="34" charset="-120"/>
                         </a:rPr>
-                        <a:t>Micro recall</a:t>
+                        <a:t>Precision</a:t>
                       </a:r>
                       <a:endParaRPr lang="en-US" sz="1100" dirty="0">
                         <a:latin typeface="Arial" charset="0"/>
@@ -5926,7 +6479,7 @@
                           <a:ea typeface="Arial" pitchFamily="34" charset="-122"/>
                           <a:cs typeface="Arial" pitchFamily="34" charset="-120"/>
                         </a:rPr>
-                        <a:t>Invariant-class leaks</a:t>
+                        <a:t>Recall</a:t>
                       </a:r>
                       <a:endParaRPr lang="en-US" sz="1100" dirty="0">
                         <a:latin typeface="Arial" charset="0"/>
@@ -5975,6 +6528,73 @@
                     <a:solidFill>
                       <a:srgbClr val="1F4E79"/>
                     </a:solidFill>
+                  </a:tcPr>
+                </a:tc>
+              </a:tr>
+              <a:tr h="365760">
+                <a:tc>
+                  <a:txBody>
+                    <a:bodyPr/>
+                    <a:lstStyle/>
+                    <a:p>
+                      <a:pPr indent="0" marL="0">
+                        <a:buNone/>
+                      </a:pPr>
+                      <a:r>
+                        <a:rPr lang="en-US" sz="1050" dirty="0">
+                          <a:solidFill>
+                            <a:srgbClr val="16181D"/>
+                          </a:solidFill>
+                          <a:latin typeface="Arial" pitchFamily="34" charset="0"/>
+                          <a:ea typeface="Arial" pitchFamily="34" charset="-122"/>
+                          <a:cs typeface="Arial" pitchFamily="34" charset="-120"/>
+                        </a:rPr>
+                        <a:t>Govt IDs: Aadhaar, PAN, GSTIN (checksums)</a:t>
+                      </a:r>
+                      <a:endParaRPr lang="en-US" sz="1050" dirty="0">
+                        <a:latin typeface="Arial" charset="0"/>
+                        <a:ea typeface="Arial" charset="0"/>
+                        <a:cs typeface="Arial" charset="0"/>
+                      </a:endParaRPr>
+                    </a:p>
+                  </a:txBody>
+                  <a:tcPr marL="91440" marR="91440" marT="45720" marB="45720" anchor="ctr">
+                    <a:lnL w="6350" cap="flat" cmpd="sng" algn="ctr">
+                      <a:solidFill>
+                        <a:srgbClr val="D6DAE0"/>
+                      </a:solidFill>
+                      <a:prstDash val="solid"/>
+                      <a:round/>
+                      <a:headEnd type="none" w="med" len="med"/>
+                      <a:tailEnd type="none" w="med" len="med"/>
+                    </a:lnL>
+                    <a:lnR w="6350" cap="flat" cmpd="sng" algn="ctr">
+                      <a:solidFill>
+                        <a:srgbClr val="D6DAE0"/>
+                      </a:solidFill>
+                      <a:prstDash val="solid"/>
+                      <a:round/>
+                      <a:headEnd type="none" w="med" len="med"/>
+                      <a:tailEnd type="none" w="med" len="med"/>
+                    </a:lnR>
+                    <a:lnT w="6350" cap="flat" cmpd="sng" algn="ctr">
+                      <a:solidFill>
+                        <a:srgbClr val="D6DAE0"/>
+                      </a:solidFill>
+                      <a:prstDash val="solid"/>
+                      <a:round/>
+                      <a:headEnd type="none" w="med" len="med"/>
+                      <a:tailEnd type="none" w="med" len="med"/>
+                    </a:lnT>
+                    <a:lnB w="6350" cap="flat" cmpd="sng" algn="ctr">
+                      <a:solidFill>
+                        <a:srgbClr val="D6DAE0"/>
+                      </a:solidFill>
+                      <a:prstDash val="solid"/>
+                      <a:round/>
+                      <a:headEnd type="none" w="med" len="med"/>
+                      <a:tailEnd type="none" w="med" len="med"/>
+                    </a:lnB>
                   </a:tcPr>
                 </a:tc>
                 <a:tc>
@@ -5986,77 +6606,7 @@
                         <a:buNone/>
                       </a:pPr>
                       <a:r>
-                        <a:rPr lang="en-US" sz="1100" b="1" dirty="0">
-                          <a:solidFill>
-                            <a:srgbClr val="FFFFFF"/>
-                          </a:solidFill>
-                          <a:latin typeface="Arial" pitchFamily="34" charset="0"/>
-                          <a:ea typeface="Arial" pitchFamily="34" charset="-122"/>
-                          <a:cs typeface="Arial" pitchFamily="34" charset="-120"/>
-                        </a:rPr>
-                        <a:t>False alarms on negatives</a:t>
-                      </a:r>
-                      <a:endParaRPr lang="en-US" sz="1100" dirty="0">
-                        <a:latin typeface="Arial" charset="0"/>
-                        <a:ea typeface="Arial" charset="0"/>
-                        <a:cs typeface="Arial" charset="0"/>
-                      </a:endParaRPr>
-                    </a:p>
-                  </a:txBody>
-                  <a:tcPr marL="91440" marR="91440" marT="45720" marB="45720" anchor="ctr">
-                    <a:lnL w="6350" cap="flat" cmpd="sng" algn="ctr">
-                      <a:solidFill>
-                        <a:srgbClr val="D6DAE0"/>
-                      </a:solidFill>
-                      <a:prstDash val="solid"/>
-                      <a:round/>
-                      <a:headEnd type="none" w="med" len="med"/>
-                      <a:tailEnd type="none" w="med" len="med"/>
-                    </a:lnL>
-                    <a:lnR w="6350" cap="flat" cmpd="sng" algn="ctr">
-                      <a:solidFill>
-                        <a:srgbClr val="D6DAE0"/>
-                      </a:solidFill>
-                      <a:prstDash val="solid"/>
-                      <a:round/>
-                      <a:headEnd type="none" w="med" len="med"/>
-                      <a:tailEnd type="none" w="med" len="med"/>
-                    </a:lnR>
-                    <a:lnT w="6350" cap="flat" cmpd="sng" algn="ctr">
-                      <a:solidFill>
-                        <a:srgbClr val="D6DAE0"/>
-                      </a:solidFill>
-                      <a:prstDash val="solid"/>
-                      <a:round/>
-                      <a:headEnd type="none" w="med" len="med"/>
-                      <a:tailEnd type="none" w="med" len="med"/>
-                    </a:lnT>
-                    <a:lnB w="6350" cap="flat" cmpd="sng" algn="ctr">
-                      <a:solidFill>
-                        <a:srgbClr val="D6DAE0"/>
-                      </a:solidFill>
-                      <a:prstDash val="solid"/>
-                      <a:round/>
-                      <a:headEnd type="none" w="med" len="med"/>
-                      <a:tailEnd type="none" w="med" len="med"/>
-                    </a:lnB>
-                    <a:solidFill>
-                      <a:srgbClr val="1F4E79"/>
-                    </a:solidFill>
-                  </a:tcPr>
-                </a:tc>
-              </a:tr>
-              <a:tr h="502920">
-                <a:tc>
-                  <a:txBody>
-                    <a:bodyPr/>
-                    <a:lstStyle/>
-                    <a:p>
-                      <a:pPr indent="0" marL="0">
-                        <a:buNone/>
-                      </a:pPr>
-                      <a:r>
-                        <a:rPr lang="en-US" sz="1050" b="1" dirty="0">
+                        <a:rPr lang="en-US" sz="1050" dirty="0">
                           <a:solidFill>
                             <a:srgbClr val="16181D"/>
                           </a:solidFill>
@@ -6064,7 +6614,7 @@
                           <a:ea typeface="Arial" pitchFamily="34" charset="-122"/>
                           <a:cs typeface="Arial" pitchFamily="34" charset="-120"/>
                         </a:rPr>
-                        <a:t>Shield</a:t>
+                        <a:t>7</a:t>
                       </a:r>
                       <a:endParaRPr lang="en-US" sz="1050" dirty="0">
                         <a:latin typeface="Arial" charset="0"/>
@@ -6186,6 +6736,73 @@
                         <a:buNone/>
                       </a:pPr>
                       <a:r>
+                        <a:rPr lang="en-US" sz="1050" b="1" dirty="0">
+                          <a:solidFill>
+                            <a:srgbClr val="3D5A3D"/>
+                          </a:solidFill>
+                          <a:latin typeface="Arial" pitchFamily="34" charset="0"/>
+                          <a:ea typeface="Arial" pitchFamily="34" charset="-122"/>
+                          <a:cs typeface="Arial" pitchFamily="34" charset="-120"/>
+                        </a:rPr>
+                        <a:t>100%</a:t>
+                      </a:r>
+                      <a:endParaRPr lang="en-US" sz="1050" dirty="0">
+                        <a:latin typeface="Arial" charset="0"/>
+                        <a:ea typeface="Arial" charset="0"/>
+                        <a:cs typeface="Arial" charset="0"/>
+                      </a:endParaRPr>
+                    </a:p>
+                  </a:txBody>
+                  <a:tcPr marL="91440" marR="91440" marT="45720" marB="45720" anchor="ctr">
+                    <a:lnL w="6350" cap="flat" cmpd="sng" algn="ctr">
+                      <a:solidFill>
+                        <a:srgbClr val="D6DAE0"/>
+                      </a:solidFill>
+                      <a:prstDash val="solid"/>
+                      <a:round/>
+                      <a:headEnd type="none" w="med" len="med"/>
+                      <a:tailEnd type="none" w="med" len="med"/>
+                    </a:lnL>
+                    <a:lnR w="6350" cap="flat" cmpd="sng" algn="ctr">
+                      <a:solidFill>
+                        <a:srgbClr val="D6DAE0"/>
+                      </a:solidFill>
+                      <a:prstDash val="solid"/>
+                      <a:round/>
+                      <a:headEnd type="none" w="med" len="med"/>
+                      <a:tailEnd type="none" w="med" len="med"/>
+                    </a:lnR>
+                    <a:lnT w="6350" cap="flat" cmpd="sng" algn="ctr">
+                      <a:solidFill>
+                        <a:srgbClr val="D6DAE0"/>
+                      </a:solidFill>
+                      <a:prstDash val="solid"/>
+                      <a:round/>
+                      <a:headEnd type="none" w="med" len="med"/>
+                      <a:tailEnd type="none" w="med" len="med"/>
+                    </a:lnT>
+                    <a:lnB w="6350" cap="flat" cmpd="sng" algn="ctr">
+                      <a:solidFill>
+                        <a:srgbClr val="D6DAE0"/>
+                      </a:solidFill>
+                      <a:prstDash val="solid"/>
+                      <a:round/>
+                      <a:headEnd type="none" w="med" len="med"/>
+                      <a:tailEnd type="none" w="med" len="med"/>
+                    </a:lnB>
+                  </a:tcPr>
+                </a:tc>
+              </a:tr>
+              <a:tr h="365760">
+                <a:tc>
+                  <a:txBody>
+                    <a:bodyPr/>
+                    <a:lstStyle/>
+                    <a:p>
+                      <a:pPr indent="0" marL="0">
+                        <a:buNone/>
+                      </a:pPr>
+                      <a:r>
                         <a:rPr lang="en-US" sz="1050" dirty="0">
                           <a:solidFill>
                             <a:srgbClr val="16181D"/>
@@ -6194,7 +6811,72 @@
                           <a:ea typeface="Arial" pitchFamily="34" charset="-122"/>
                           <a:cs typeface="Arial" pitchFamily="34" charset="-120"/>
                         </a:rPr>
-                        <a:t>91.4%</a:t>
+                        <a:t>Financial: card, IFSC, bank a/c, UPI, amounts</a:t>
+                      </a:r>
+                      <a:endParaRPr lang="en-US" sz="1050" dirty="0">
+                        <a:latin typeface="Arial" charset="0"/>
+                        <a:ea typeface="Arial" charset="0"/>
+                        <a:cs typeface="Arial" charset="0"/>
+                      </a:endParaRPr>
+                    </a:p>
+                  </a:txBody>
+                  <a:tcPr marL="91440" marR="91440" marT="45720" marB="45720" anchor="ctr">
+                    <a:lnL w="6350" cap="flat" cmpd="sng" algn="ctr">
+                      <a:solidFill>
+                        <a:srgbClr val="D6DAE0"/>
+                      </a:solidFill>
+                      <a:prstDash val="solid"/>
+                      <a:round/>
+                      <a:headEnd type="none" w="med" len="med"/>
+                      <a:tailEnd type="none" w="med" len="med"/>
+                    </a:lnL>
+                    <a:lnR w="6350" cap="flat" cmpd="sng" algn="ctr">
+                      <a:solidFill>
+                        <a:srgbClr val="D6DAE0"/>
+                      </a:solidFill>
+                      <a:prstDash val="solid"/>
+                      <a:round/>
+                      <a:headEnd type="none" w="med" len="med"/>
+                      <a:tailEnd type="none" w="med" len="med"/>
+                    </a:lnR>
+                    <a:lnT w="6350" cap="flat" cmpd="sng" algn="ctr">
+                      <a:solidFill>
+                        <a:srgbClr val="D6DAE0"/>
+                      </a:solidFill>
+                      <a:prstDash val="solid"/>
+                      <a:round/>
+                      <a:headEnd type="none" w="med" len="med"/>
+                      <a:tailEnd type="none" w="med" len="med"/>
+                    </a:lnT>
+                    <a:lnB w="6350" cap="flat" cmpd="sng" algn="ctr">
+                      <a:solidFill>
+                        <a:srgbClr val="D6DAE0"/>
+                      </a:solidFill>
+                      <a:prstDash val="solid"/>
+                      <a:round/>
+                      <a:headEnd type="none" w="med" len="med"/>
+                      <a:tailEnd type="none" w="med" len="med"/>
+                    </a:lnB>
+                  </a:tcPr>
+                </a:tc>
+                <a:tc>
+                  <a:txBody>
+                    <a:bodyPr/>
+                    <a:lstStyle/>
+                    <a:p>
+                      <a:pPr indent="0" marL="0">
+                        <a:buNone/>
+                      </a:pPr>
+                      <a:r>
+                        <a:rPr lang="en-US" sz="1050" dirty="0">
+                          <a:solidFill>
+                            <a:srgbClr val="16181D"/>
+                          </a:solidFill>
+                          <a:latin typeface="Arial" pitchFamily="34" charset="0"/>
+                          <a:ea typeface="Arial" pitchFamily="34" charset="-122"/>
+                          <a:cs typeface="Arial" pitchFamily="34" charset="-120"/>
+                        </a:rPr>
+                        <a:t>8</a:t>
                       </a:r>
                       <a:endParaRPr lang="en-US" sz="1050" dirty="0">
                         <a:latin typeface="Arial" charset="0"/>
@@ -6259,7 +6941,7 @@
                           <a:ea typeface="Arial" pitchFamily="34" charset="-122"/>
                           <a:cs typeface="Arial" pitchFamily="34" charset="-120"/>
                         </a:rPr>
-                        <a:t>0</a:t>
+                        <a:t>100%</a:t>
                       </a:r>
                       <a:endParaRPr lang="en-US" sz="1050" dirty="0">
                         <a:latin typeface="Arial" charset="0"/>
@@ -6324,7 +7006,7 @@
                           <a:ea typeface="Arial" pitchFamily="34" charset="-122"/>
                           <a:cs typeface="Arial" pitchFamily="34" charset="-120"/>
                         </a:rPr>
-                        <a:t>0</a:t>
+                        <a:t>100%</a:t>
                       </a:r>
                       <a:endParaRPr lang="en-US" sz="1050" dirty="0">
                         <a:latin typeface="Arial" charset="0"/>
@@ -6373,7 +7055,7 @@
                   </a:tcPr>
                 </a:tc>
               </a:tr>
-              <a:tr h="502920">
+              <a:tr h="365760">
                 <a:tc>
                   <a:txBody>
                     <a:bodyPr/>
@@ -6383,7 +7065,7 @@
                         <a:buNone/>
                       </a:pPr>
                       <a:r>
-                        <a:rPr lang="en-US" sz="1050" b="1" dirty="0">
+                        <a:rPr lang="en-US" sz="1050" dirty="0">
                           <a:solidFill>
                             <a:srgbClr val="16181D"/>
                           </a:solidFill>
@@ -6391,7 +7073,7 @@
                           <a:ea typeface="Arial" pitchFamily="34" charset="-122"/>
                           <a:cs typeface="Arial" pitchFamily="34" charset="-120"/>
                         </a:rPr>
-                        <a:t>Fortress</a:t>
+                        <a:t>Contact: email, phone (IN)</a:t>
                       </a:r>
                       <a:endParaRPr lang="en-US" sz="1050" dirty="0">
                         <a:latin typeface="Arial" charset="0"/>
@@ -6456,7 +7138,204 @@
                           <a:ea typeface="Arial" pitchFamily="34" charset="-122"/>
                           <a:cs typeface="Arial" pitchFamily="34" charset="-120"/>
                         </a:rPr>
-                        <a:t>97.1%</a:t>
+                        <a:t>9</a:t>
+                      </a:r>
+                      <a:endParaRPr lang="en-US" sz="1050" dirty="0">
+                        <a:latin typeface="Arial" charset="0"/>
+                        <a:ea typeface="Arial" charset="0"/>
+                        <a:cs typeface="Arial" charset="0"/>
+                      </a:endParaRPr>
+                    </a:p>
+                  </a:txBody>
+                  <a:tcPr marL="91440" marR="91440" marT="45720" marB="45720" anchor="ctr">
+                    <a:lnL w="6350" cap="flat" cmpd="sng" algn="ctr">
+                      <a:solidFill>
+                        <a:srgbClr val="D6DAE0"/>
+                      </a:solidFill>
+                      <a:prstDash val="solid"/>
+                      <a:round/>
+                      <a:headEnd type="none" w="med" len="med"/>
+                      <a:tailEnd type="none" w="med" len="med"/>
+                    </a:lnL>
+                    <a:lnR w="6350" cap="flat" cmpd="sng" algn="ctr">
+                      <a:solidFill>
+                        <a:srgbClr val="D6DAE0"/>
+                      </a:solidFill>
+                      <a:prstDash val="solid"/>
+                      <a:round/>
+                      <a:headEnd type="none" w="med" len="med"/>
+                      <a:tailEnd type="none" w="med" len="med"/>
+                    </a:lnR>
+                    <a:lnT w="6350" cap="flat" cmpd="sng" algn="ctr">
+                      <a:solidFill>
+                        <a:srgbClr val="D6DAE0"/>
+                      </a:solidFill>
+                      <a:prstDash val="solid"/>
+                      <a:round/>
+                      <a:headEnd type="none" w="med" len="med"/>
+                      <a:tailEnd type="none" w="med" len="med"/>
+                    </a:lnT>
+                    <a:lnB w="6350" cap="flat" cmpd="sng" algn="ctr">
+                      <a:solidFill>
+                        <a:srgbClr val="D6DAE0"/>
+                      </a:solidFill>
+                      <a:prstDash val="solid"/>
+                      <a:round/>
+                      <a:headEnd type="none" w="med" len="med"/>
+                      <a:tailEnd type="none" w="med" len="med"/>
+                    </a:lnB>
+                  </a:tcPr>
+                </a:tc>
+                <a:tc>
+                  <a:txBody>
+                    <a:bodyPr/>
+                    <a:lstStyle/>
+                    <a:p>
+                      <a:pPr indent="0" marL="0">
+                        <a:buNone/>
+                      </a:pPr>
+                      <a:r>
+                        <a:rPr lang="en-US" sz="1050" b="1" dirty="0">
+                          <a:solidFill>
+                            <a:srgbClr val="3D5A3D"/>
+                          </a:solidFill>
+                          <a:latin typeface="Arial" pitchFamily="34" charset="0"/>
+                          <a:ea typeface="Arial" pitchFamily="34" charset="-122"/>
+                          <a:cs typeface="Arial" pitchFamily="34" charset="-120"/>
+                        </a:rPr>
+                        <a:t>100%</a:t>
+                      </a:r>
+                      <a:endParaRPr lang="en-US" sz="1050" dirty="0">
+                        <a:latin typeface="Arial" charset="0"/>
+                        <a:ea typeface="Arial" charset="0"/>
+                        <a:cs typeface="Arial" charset="0"/>
+                      </a:endParaRPr>
+                    </a:p>
+                  </a:txBody>
+                  <a:tcPr marL="91440" marR="91440" marT="45720" marB="45720" anchor="ctr">
+                    <a:lnL w="6350" cap="flat" cmpd="sng" algn="ctr">
+                      <a:solidFill>
+                        <a:srgbClr val="D6DAE0"/>
+                      </a:solidFill>
+                      <a:prstDash val="solid"/>
+                      <a:round/>
+                      <a:headEnd type="none" w="med" len="med"/>
+                      <a:tailEnd type="none" w="med" len="med"/>
+                    </a:lnL>
+                    <a:lnR w="6350" cap="flat" cmpd="sng" algn="ctr">
+                      <a:solidFill>
+                        <a:srgbClr val="D6DAE0"/>
+                      </a:solidFill>
+                      <a:prstDash val="solid"/>
+                      <a:round/>
+                      <a:headEnd type="none" w="med" len="med"/>
+                      <a:tailEnd type="none" w="med" len="med"/>
+                    </a:lnR>
+                    <a:lnT w="6350" cap="flat" cmpd="sng" algn="ctr">
+                      <a:solidFill>
+                        <a:srgbClr val="D6DAE0"/>
+                      </a:solidFill>
+                      <a:prstDash val="solid"/>
+                      <a:round/>
+                      <a:headEnd type="none" w="med" len="med"/>
+                      <a:tailEnd type="none" w="med" len="med"/>
+                    </a:lnT>
+                    <a:lnB w="6350" cap="flat" cmpd="sng" algn="ctr">
+                      <a:solidFill>
+                        <a:srgbClr val="D6DAE0"/>
+                      </a:solidFill>
+                      <a:prstDash val="solid"/>
+                      <a:round/>
+                      <a:headEnd type="none" w="med" len="med"/>
+                      <a:tailEnd type="none" w="med" len="med"/>
+                    </a:lnB>
+                  </a:tcPr>
+                </a:tc>
+                <a:tc>
+                  <a:txBody>
+                    <a:bodyPr/>
+                    <a:lstStyle/>
+                    <a:p>
+                      <a:pPr indent="0" marL="0">
+                        <a:buNone/>
+                      </a:pPr>
+                      <a:r>
+                        <a:rPr lang="en-US" sz="1050" b="1" dirty="0">
+                          <a:solidFill>
+                            <a:srgbClr val="3D5A3D"/>
+                          </a:solidFill>
+                          <a:latin typeface="Arial" pitchFamily="34" charset="0"/>
+                          <a:ea typeface="Arial" pitchFamily="34" charset="-122"/>
+                          <a:cs typeface="Arial" pitchFamily="34" charset="-120"/>
+                        </a:rPr>
+                        <a:t>100%</a:t>
+                      </a:r>
+                      <a:endParaRPr lang="en-US" sz="1050" dirty="0">
+                        <a:latin typeface="Arial" charset="0"/>
+                        <a:ea typeface="Arial" charset="0"/>
+                        <a:cs typeface="Arial" charset="0"/>
+                      </a:endParaRPr>
+                    </a:p>
+                  </a:txBody>
+                  <a:tcPr marL="91440" marR="91440" marT="45720" marB="45720" anchor="ctr">
+                    <a:lnL w="6350" cap="flat" cmpd="sng" algn="ctr">
+                      <a:solidFill>
+                        <a:srgbClr val="D6DAE0"/>
+                      </a:solidFill>
+                      <a:prstDash val="solid"/>
+                      <a:round/>
+                      <a:headEnd type="none" w="med" len="med"/>
+                      <a:tailEnd type="none" w="med" len="med"/>
+                    </a:lnL>
+                    <a:lnR w="6350" cap="flat" cmpd="sng" algn="ctr">
+                      <a:solidFill>
+                        <a:srgbClr val="D6DAE0"/>
+                      </a:solidFill>
+                      <a:prstDash val="solid"/>
+                      <a:round/>
+                      <a:headEnd type="none" w="med" len="med"/>
+                      <a:tailEnd type="none" w="med" len="med"/>
+                    </a:lnR>
+                    <a:lnT w="6350" cap="flat" cmpd="sng" algn="ctr">
+                      <a:solidFill>
+                        <a:srgbClr val="D6DAE0"/>
+                      </a:solidFill>
+                      <a:prstDash val="solid"/>
+                      <a:round/>
+                      <a:headEnd type="none" w="med" len="med"/>
+                      <a:tailEnd type="none" w="med" len="med"/>
+                    </a:lnT>
+                    <a:lnB w="6350" cap="flat" cmpd="sng" algn="ctr">
+                      <a:solidFill>
+                        <a:srgbClr val="D6DAE0"/>
+                      </a:solidFill>
+                      <a:prstDash val="solid"/>
+                      <a:round/>
+                      <a:headEnd type="none" w="med" len="med"/>
+                      <a:tailEnd type="none" w="med" len="med"/>
+                    </a:lnB>
+                  </a:tcPr>
+                </a:tc>
+              </a:tr>
+              <a:tr h="365760">
+                <a:tc>
+                  <a:txBody>
+                    <a:bodyPr/>
+                    <a:lstStyle/>
+                    <a:p>
+                      <a:pPr indent="0" marL="0">
+                        <a:buNone/>
+                      </a:pPr>
+                      <a:r>
+                        <a:rPr lang="en-US" sz="1050" dirty="0">
+                          <a:solidFill>
+                            <a:srgbClr val="16181D"/>
+                          </a:solidFill>
+                          <a:latin typeface="Arial" pitchFamily="34" charset="0"/>
+                          <a:ea typeface="Arial" pitchFamily="34" charset="-122"/>
+                          <a:cs typeface="Arial" pitchFamily="34" charset="-120"/>
+                        </a:rPr>
+                        <a:t>Visual: faces, QR, unexplained media</a:t>
                       </a:r>
                       <a:endParaRPr lang="en-US" sz="1050" dirty="0">
                         <a:latin typeface="Arial" charset="0"/>
@@ -6521,7 +7400,7 @@
                           <a:ea typeface="Arial" pitchFamily="34" charset="-122"/>
                           <a:cs typeface="Arial" pitchFamily="34" charset="-120"/>
                         </a:rPr>
-                        <a:t>94.3%</a:t>
+                        <a:t>5</a:t>
                       </a:r>
                       <a:endParaRPr lang="en-US" sz="1050" dirty="0">
                         <a:latin typeface="Arial" charset="0"/>
@@ -6586,7 +7465,139 @@
                           <a:ea typeface="Arial" pitchFamily="34" charset="-122"/>
                           <a:cs typeface="Arial" pitchFamily="34" charset="-120"/>
                         </a:rPr>
-                        <a:t>0</a:t>
+                        <a:t>100%</a:t>
+                      </a:r>
+                      <a:endParaRPr lang="en-US" sz="1050" dirty="0">
+                        <a:latin typeface="Arial" charset="0"/>
+                        <a:ea typeface="Arial" charset="0"/>
+                        <a:cs typeface="Arial" charset="0"/>
+                      </a:endParaRPr>
+                    </a:p>
+                  </a:txBody>
+                  <a:tcPr marL="91440" marR="91440" marT="45720" marB="45720" anchor="ctr">
+                    <a:lnL w="6350" cap="flat" cmpd="sng" algn="ctr">
+                      <a:solidFill>
+                        <a:srgbClr val="D6DAE0"/>
+                      </a:solidFill>
+                      <a:prstDash val="solid"/>
+                      <a:round/>
+                      <a:headEnd type="none" w="med" len="med"/>
+                      <a:tailEnd type="none" w="med" len="med"/>
+                    </a:lnL>
+                    <a:lnR w="6350" cap="flat" cmpd="sng" algn="ctr">
+                      <a:solidFill>
+                        <a:srgbClr val="D6DAE0"/>
+                      </a:solidFill>
+                      <a:prstDash val="solid"/>
+                      <a:round/>
+                      <a:headEnd type="none" w="med" len="med"/>
+                      <a:tailEnd type="none" w="med" len="med"/>
+                    </a:lnR>
+                    <a:lnT w="6350" cap="flat" cmpd="sng" algn="ctr">
+                      <a:solidFill>
+                        <a:srgbClr val="D6DAE0"/>
+                      </a:solidFill>
+                      <a:prstDash val="solid"/>
+                      <a:round/>
+                      <a:headEnd type="none" w="med" len="med"/>
+                      <a:tailEnd type="none" w="med" len="med"/>
+                    </a:lnT>
+                    <a:lnB w="6350" cap="flat" cmpd="sng" algn="ctr">
+                      <a:solidFill>
+                        <a:srgbClr val="D6DAE0"/>
+                      </a:solidFill>
+                      <a:prstDash val="solid"/>
+                      <a:round/>
+                      <a:headEnd type="none" w="med" len="med"/>
+                      <a:tailEnd type="none" w="med" len="med"/>
+                    </a:lnB>
+                  </a:tcPr>
+                </a:tc>
+                <a:tc>
+                  <a:txBody>
+                    <a:bodyPr/>
+                    <a:lstStyle/>
+                    <a:p>
+                      <a:pPr indent="0" marL="0">
+                        <a:buNone/>
+                      </a:pPr>
+                      <a:r>
+                        <a:rPr lang="en-US" sz="1050" b="1" dirty="0">
+                          <a:solidFill>
+                            <a:srgbClr val="3D5A3D"/>
+                          </a:solidFill>
+                          <a:latin typeface="Arial" pitchFamily="34" charset="0"/>
+                          <a:ea typeface="Arial" pitchFamily="34" charset="-122"/>
+                          <a:cs typeface="Arial" pitchFamily="34" charset="-120"/>
+                        </a:rPr>
+                        <a:t>100%</a:t>
+                      </a:r>
+                      <a:endParaRPr lang="en-US" sz="1050" dirty="0">
+                        <a:latin typeface="Arial" charset="0"/>
+                        <a:ea typeface="Arial" charset="0"/>
+                        <a:cs typeface="Arial" charset="0"/>
+                      </a:endParaRPr>
+                    </a:p>
+                  </a:txBody>
+                  <a:tcPr marL="91440" marR="91440" marT="45720" marB="45720" anchor="ctr">
+                    <a:lnL w="6350" cap="flat" cmpd="sng" algn="ctr">
+                      <a:solidFill>
+                        <a:srgbClr val="D6DAE0"/>
+                      </a:solidFill>
+                      <a:prstDash val="solid"/>
+                      <a:round/>
+                      <a:headEnd type="none" w="med" len="med"/>
+                      <a:tailEnd type="none" w="med" len="med"/>
+                    </a:lnL>
+                    <a:lnR w="6350" cap="flat" cmpd="sng" algn="ctr">
+                      <a:solidFill>
+                        <a:srgbClr val="D6DAE0"/>
+                      </a:solidFill>
+                      <a:prstDash val="solid"/>
+                      <a:round/>
+                      <a:headEnd type="none" w="med" len="med"/>
+                      <a:tailEnd type="none" w="med" len="med"/>
+                    </a:lnR>
+                    <a:lnT w="6350" cap="flat" cmpd="sng" algn="ctr">
+                      <a:solidFill>
+                        <a:srgbClr val="D6DAE0"/>
+                      </a:solidFill>
+                      <a:prstDash val="solid"/>
+                      <a:round/>
+                      <a:headEnd type="none" w="med" len="med"/>
+                      <a:tailEnd type="none" w="med" len="med"/>
+                    </a:lnT>
+                    <a:lnB w="6350" cap="flat" cmpd="sng" algn="ctr">
+                      <a:solidFill>
+                        <a:srgbClr val="D6DAE0"/>
+                      </a:solidFill>
+                      <a:prstDash val="solid"/>
+                      <a:round/>
+                      <a:headEnd type="none" w="med" len="med"/>
+                      <a:tailEnd type="none" w="med" len="med"/>
+                    </a:lnB>
+                  </a:tcPr>
+                </a:tc>
+              </a:tr>
+              <a:tr h="365760">
+                <a:tc>
+                  <a:txBody>
+                    <a:bodyPr/>
+                    <a:lstStyle/>
+                    <a:p>
+                      <a:pPr indent="0" marL="0">
+                        <a:buNone/>
+                      </a:pPr>
+                      <a:r>
+                        <a:rPr lang="en-US" sz="1050" dirty="0">
+                          <a:solidFill>
+                            <a:srgbClr val="16181D"/>
+                          </a:solidFill>
+                          <a:latin typeface="Arial" pitchFamily="34" charset="0"/>
+                          <a:ea typeface="Arial" pitchFamily="34" charset="-122"/>
+                          <a:cs typeface="Arial" pitchFamily="34" charset="-120"/>
+                        </a:rPr>
+                        <a:t>DOB, vehicle registration</a:t>
                       </a:r>
                       <a:endParaRPr lang="en-US" sz="1050" dirty="0">
                         <a:latin typeface="Arial" charset="0"/>
@@ -6651,7 +7662,7 @@
                           <a:ea typeface="Arial" pitchFamily="34" charset="-122"/>
                           <a:cs typeface="Arial" pitchFamily="34" charset="-120"/>
                         </a:rPr>
-                        <a:t>1 (an appointment date)</a:t>
+                        <a:t>2</a:t>
                       </a:r>
                       <a:endParaRPr lang="en-US" sz="1050" dirty="0">
                         <a:latin typeface="Arial" charset="0"/>
@@ -6699,6 +7710,922 @@
                     </a:lnB>
                   </a:tcPr>
                 </a:tc>
+                <a:tc>
+                  <a:txBody>
+                    <a:bodyPr/>
+                    <a:lstStyle/>
+                    <a:p>
+                      <a:pPr indent="0" marL="0">
+                        <a:buNone/>
+                      </a:pPr>
+                      <a:r>
+                        <a:rPr lang="en-US" sz="1050" b="1" dirty="0">
+                          <a:solidFill>
+                            <a:srgbClr val="3D5A3D"/>
+                          </a:solidFill>
+                          <a:latin typeface="Arial" pitchFamily="34" charset="0"/>
+                          <a:ea typeface="Arial" pitchFamily="34" charset="-122"/>
+                          <a:cs typeface="Arial" pitchFamily="34" charset="-120"/>
+                        </a:rPr>
+                        <a:t>100%</a:t>
+                      </a:r>
+                      <a:endParaRPr lang="en-US" sz="1050" dirty="0">
+                        <a:latin typeface="Arial" charset="0"/>
+                        <a:ea typeface="Arial" charset="0"/>
+                        <a:cs typeface="Arial" charset="0"/>
+                      </a:endParaRPr>
+                    </a:p>
+                  </a:txBody>
+                  <a:tcPr marL="91440" marR="91440" marT="45720" marB="45720" anchor="ctr">
+                    <a:lnL w="6350" cap="flat" cmpd="sng" algn="ctr">
+                      <a:solidFill>
+                        <a:srgbClr val="D6DAE0"/>
+                      </a:solidFill>
+                      <a:prstDash val="solid"/>
+                      <a:round/>
+                      <a:headEnd type="none" w="med" len="med"/>
+                      <a:tailEnd type="none" w="med" len="med"/>
+                    </a:lnL>
+                    <a:lnR w="6350" cap="flat" cmpd="sng" algn="ctr">
+                      <a:solidFill>
+                        <a:srgbClr val="D6DAE0"/>
+                      </a:solidFill>
+                      <a:prstDash val="solid"/>
+                      <a:round/>
+                      <a:headEnd type="none" w="med" len="med"/>
+                      <a:tailEnd type="none" w="med" len="med"/>
+                    </a:lnR>
+                    <a:lnT w="6350" cap="flat" cmpd="sng" algn="ctr">
+                      <a:solidFill>
+                        <a:srgbClr val="D6DAE0"/>
+                      </a:solidFill>
+                      <a:prstDash val="solid"/>
+                      <a:round/>
+                      <a:headEnd type="none" w="med" len="med"/>
+                      <a:tailEnd type="none" w="med" len="med"/>
+                    </a:lnT>
+                    <a:lnB w="6350" cap="flat" cmpd="sng" algn="ctr">
+                      <a:solidFill>
+                        <a:srgbClr val="D6DAE0"/>
+                      </a:solidFill>
+                      <a:prstDash val="solid"/>
+                      <a:round/>
+                      <a:headEnd type="none" w="med" len="med"/>
+                      <a:tailEnd type="none" w="med" len="med"/>
+                    </a:lnB>
+                  </a:tcPr>
+                </a:tc>
+                <a:tc>
+                  <a:txBody>
+                    <a:bodyPr/>
+                    <a:lstStyle/>
+                    <a:p>
+                      <a:pPr indent="0" marL="0">
+                        <a:buNone/>
+                      </a:pPr>
+                      <a:r>
+                        <a:rPr lang="en-US" sz="1050" b="1" dirty="0">
+                          <a:solidFill>
+                            <a:srgbClr val="3D5A3D"/>
+                          </a:solidFill>
+                          <a:latin typeface="Arial" pitchFamily="34" charset="0"/>
+                          <a:ea typeface="Arial" pitchFamily="34" charset="-122"/>
+                          <a:cs typeface="Arial" pitchFamily="34" charset="-120"/>
+                        </a:rPr>
+                        <a:t>100%</a:t>
+                      </a:r>
+                      <a:endParaRPr lang="en-US" sz="1050" dirty="0">
+                        <a:latin typeface="Arial" charset="0"/>
+                        <a:ea typeface="Arial" charset="0"/>
+                        <a:cs typeface="Arial" charset="0"/>
+                      </a:endParaRPr>
+                    </a:p>
+                  </a:txBody>
+                  <a:tcPr marL="91440" marR="91440" marT="45720" marB="45720" anchor="ctr">
+                    <a:lnL w="6350" cap="flat" cmpd="sng" algn="ctr">
+                      <a:solidFill>
+                        <a:srgbClr val="D6DAE0"/>
+                      </a:solidFill>
+                      <a:prstDash val="solid"/>
+                      <a:round/>
+                      <a:headEnd type="none" w="med" len="med"/>
+                      <a:tailEnd type="none" w="med" len="med"/>
+                    </a:lnL>
+                    <a:lnR w="6350" cap="flat" cmpd="sng" algn="ctr">
+                      <a:solidFill>
+                        <a:srgbClr val="D6DAE0"/>
+                      </a:solidFill>
+                      <a:prstDash val="solid"/>
+                      <a:round/>
+                      <a:headEnd type="none" w="med" len="med"/>
+                      <a:tailEnd type="none" w="med" len="med"/>
+                    </a:lnR>
+                    <a:lnT w="6350" cap="flat" cmpd="sng" algn="ctr">
+                      <a:solidFill>
+                        <a:srgbClr val="D6DAE0"/>
+                      </a:solidFill>
+                      <a:prstDash val="solid"/>
+                      <a:round/>
+                      <a:headEnd type="none" w="med" len="med"/>
+                      <a:tailEnd type="none" w="med" len="med"/>
+                    </a:lnT>
+                    <a:lnB w="6350" cap="flat" cmpd="sng" algn="ctr">
+                      <a:solidFill>
+                        <a:srgbClr val="D6DAE0"/>
+                      </a:solidFill>
+                      <a:prstDash val="solid"/>
+                      <a:round/>
+                      <a:headEnd type="none" w="med" len="med"/>
+                      <a:tailEnd type="none" w="med" len="med"/>
+                    </a:lnB>
+                  </a:tcPr>
+                </a:tc>
+              </a:tr>
+              <a:tr h="365760">
+                <a:tc>
+                  <a:txBody>
+                    <a:bodyPr/>
+                    <a:lstStyle/>
+                    <a:p>
+                      <a:pPr indent="0" marL="0">
+                        <a:buNone/>
+                      </a:pPr>
+                      <a:r>
+                        <a:rPr lang="en-US" sz="1050" dirty="0">
+                          <a:solidFill>
+                            <a:srgbClr val="16181D"/>
+                          </a:solidFill>
+                          <a:latin typeface="Arial" pitchFamily="34" charset="0"/>
+                          <a:ea typeface="Arial" pitchFamily="34" charset="-122"/>
+                          <a:cs typeface="Arial" pitchFamily="34" charset="-120"/>
+                        </a:rPr>
+                        <a:t>Address in free text (NER tier pending)</a:t>
+                      </a:r>
+                      <a:endParaRPr lang="en-US" sz="1050" dirty="0">
+                        <a:latin typeface="Arial" charset="0"/>
+                        <a:ea typeface="Arial" charset="0"/>
+                        <a:cs typeface="Arial" charset="0"/>
+                      </a:endParaRPr>
+                    </a:p>
+                  </a:txBody>
+                  <a:tcPr marL="91440" marR="91440" marT="45720" marB="45720" anchor="ctr">
+                    <a:lnL w="6350" cap="flat" cmpd="sng" algn="ctr">
+                      <a:solidFill>
+                        <a:srgbClr val="D6DAE0"/>
+                      </a:solidFill>
+                      <a:prstDash val="solid"/>
+                      <a:round/>
+                      <a:headEnd type="none" w="med" len="med"/>
+                      <a:tailEnd type="none" w="med" len="med"/>
+                    </a:lnL>
+                    <a:lnR w="6350" cap="flat" cmpd="sng" algn="ctr">
+                      <a:solidFill>
+                        <a:srgbClr val="D6DAE0"/>
+                      </a:solidFill>
+                      <a:prstDash val="solid"/>
+                      <a:round/>
+                      <a:headEnd type="none" w="med" len="med"/>
+                      <a:tailEnd type="none" w="med" len="med"/>
+                    </a:lnR>
+                    <a:lnT w="6350" cap="flat" cmpd="sng" algn="ctr">
+                      <a:solidFill>
+                        <a:srgbClr val="D6DAE0"/>
+                      </a:solidFill>
+                      <a:prstDash val="solid"/>
+                      <a:round/>
+                      <a:headEnd type="none" w="med" len="med"/>
+                      <a:tailEnd type="none" w="med" len="med"/>
+                    </a:lnT>
+                    <a:lnB w="6350" cap="flat" cmpd="sng" algn="ctr">
+                      <a:solidFill>
+                        <a:srgbClr val="D6DAE0"/>
+                      </a:solidFill>
+                      <a:prstDash val="solid"/>
+                      <a:round/>
+                      <a:headEnd type="none" w="med" len="med"/>
+                      <a:tailEnd type="none" w="med" len="med"/>
+                    </a:lnB>
+                  </a:tcPr>
+                </a:tc>
+                <a:tc>
+                  <a:txBody>
+                    <a:bodyPr/>
+                    <a:lstStyle/>
+                    <a:p>
+                      <a:pPr indent="0" marL="0">
+                        <a:buNone/>
+                      </a:pPr>
+                      <a:r>
+                        <a:rPr lang="en-US" sz="1050" dirty="0">
+                          <a:solidFill>
+                            <a:srgbClr val="16181D"/>
+                          </a:solidFill>
+                          <a:latin typeface="Arial" pitchFamily="34" charset="0"/>
+                          <a:ea typeface="Arial" pitchFamily="34" charset="-122"/>
+                          <a:cs typeface="Arial" pitchFamily="34" charset="-120"/>
+                        </a:rPr>
+                        <a:t>2</a:t>
+                      </a:r>
+                      <a:endParaRPr lang="en-US" sz="1050" dirty="0">
+                        <a:latin typeface="Arial" charset="0"/>
+                        <a:ea typeface="Arial" charset="0"/>
+                        <a:cs typeface="Arial" charset="0"/>
+                      </a:endParaRPr>
+                    </a:p>
+                  </a:txBody>
+                  <a:tcPr marL="91440" marR="91440" marT="45720" marB="45720" anchor="ctr">
+                    <a:lnL w="6350" cap="flat" cmpd="sng" algn="ctr">
+                      <a:solidFill>
+                        <a:srgbClr val="D6DAE0"/>
+                      </a:solidFill>
+                      <a:prstDash val="solid"/>
+                      <a:round/>
+                      <a:headEnd type="none" w="med" len="med"/>
+                      <a:tailEnd type="none" w="med" len="med"/>
+                    </a:lnL>
+                    <a:lnR w="6350" cap="flat" cmpd="sng" algn="ctr">
+                      <a:solidFill>
+                        <a:srgbClr val="D6DAE0"/>
+                      </a:solidFill>
+                      <a:prstDash val="solid"/>
+                      <a:round/>
+                      <a:headEnd type="none" w="med" len="med"/>
+                      <a:tailEnd type="none" w="med" len="med"/>
+                    </a:lnR>
+                    <a:lnT w="6350" cap="flat" cmpd="sng" algn="ctr">
+                      <a:solidFill>
+                        <a:srgbClr val="D6DAE0"/>
+                      </a:solidFill>
+                      <a:prstDash val="solid"/>
+                      <a:round/>
+                      <a:headEnd type="none" w="med" len="med"/>
+                      <a:tailEnd type="none" w="med" len="med"/>
+                    </a:lnT>
+                    <a:lnB w="6350" cap="flat" cmpd="sng" algn="ctr">
+                      <a:solidFill>
+                        <a:srgbClr val="D6DAE0"/>
+                      </a:solidFill>
+                      <a:prstDash val="solid"/>
+                      <a:round/>
+                      <a:headEnd type="none" w="med" len="med"/>
+                      <a:tailEnd type="none" w="med" len="med"/>
+                    </a:lnB>
+                  </a:tcPr>
+                </a:tc>
+                <a:tc>
+                  <a:txBody>
+                    <a:bodyPr/>
+                    <a:lstStyle/>
+                    <a:p>
+                      <a:pPr indent="0" marL="0">
+                        <a:buNone/>
+                      </a:pPr>
+                      <a:r>
+                        <a:rPr lang="en-US" sz="1050" dirty="0">
+                          <a:solidFill>
+                            <a:srgbClr val="16181D"/>
+                          </a:solidFill>
+                          <a:latin typeface="Arial" pitchFamily="34" charset="0"/>
+                          <a:ea typeface="Arial" pitchFamily="34" charset="-122"/>
+                          <a:cs typeface="Arial" pitchFamily="34" charset="-120"/>
+                        </a:rPr>
+                        <a:t>100%</a:t>
+                      </a:r>
+                      <a:endParaRPr lang="en-US" sz="1050" dirty="0">
+                        <a:latin typeface="Arial" charset="0"/>
+                        <a:ea typeface="Arial" charset="0"/>
+                        <a:cs typeface="Arial" charset="0"/>
+                      </a:endParaRPr>
+                    </a:p>
+                  </a:txBody>
+                  <a:tcPr marL="91440" marR="91440" marT="45720" marB="45720" anchor="ctr">
+                    <a:lnL w="6350" cap="flat" cmpd="sng" algn="ctr">
+                      <a:solidFill>
+                        <a:srgbClr val="D6DAE0"/>
+                      </a:solidFill>
+                      <a:prstDash val="solid"/>
+                      <a:round/>
+                      <a:headEnd type="none" w="med" len="med"/>
+                      <a:tailEnd type="none" w="med" len="med"/>
+                    </a:lnL>
+                    <a:lnR w="6350" cap="flat" cmpd="sng" algn="ctr">
+                      <a:solidFill>
+                        <a:srgbClr val="D6DAE0"/>
+                      </a:solidFill>
+                      <a:prstDash val="solid"/>
+                      <a:round/>
+                      <a:headEnd type="none" w="med" len="med"/>
+                      <a:tailEnd type="none" w="med" len="med"/>
+                    </a:lnR>
+                    <a:lnT w="6350" cap="flat" cmpd="sng" algn="ctr">
+                      <a:solidFill>
+                        <a:srgbClr val="D6DAE0"/>
+                      </a:solidFill>
+                      <a:prstDash val="solid"/>
+                      <a:round/>
+                      <a:headEnd type="none" w="med" len="med"/>
+                      <a:tailEnd type="none" w="med" len="med"/>
+                    </a:lnT>
+                    <a:lnB w="6350" cap="flat" cmpd="sng" algn="ctr">
+                      <a:solidFill>
+                        <a:srgbClr val="D6DAE0"/>
+                      </a:solidFill>
+                      <a:prstDash val="solid"/>
+                      <a:round/>
+                      <a:headEnd type="none" w="med" len="med"/>
+                      <a:tailEnd type="none" w="med" len="med"/>
+                    </a:lnB>
+                  </a:tcPr>
+                </a:tc>
+                <a:tc>
+                  <a:txBody>
+                    <a:bodyPr/>
+                    <a:lstStyle/>
+                    <a:p>
+                      <a:pPr indent="0" marL="0">
+                        <a:buNone/>
+                      </a:pPr>
+                      <a:r>
+                        <a:rPr lang="en-US" sz="1050" dirty="0">
+                          <a:solidFill>
+                            <a:srgbClr val="16181D"/>
+                          </a:solidFill>
+                          <a:latin typeface="Arial" pitchFamily="34" charset="0"/>
+                          <a:ea typeface="Arial" pitchFamily="34" charset="-122"/>
+                          <a:cs typeface="Arial" pitchFamily="34" charset="-120"/>
+                        </a:rPr>
+                        <a:t>50%</a:t>
+                      </a:r>
+                      <a:endParaRPr lang="en-US" sz="1050" dirty="0">
+                        <a:latin typeface="Arial" charset="0"/>
+                        <a:ea typeface="Arial" charset="0"/>
+                        <a:cs typeface="Arial" charset="0"/>
+                      </a:endParaRPr>
+                    </a:p>
+                  </a:txBody>
+                  <a:tcPr marL="91440" marR="91440" marT="45720" marB="45720" anchor="ctr">
+                    <a:lnL w="6350" cap="flat" cmpd="sng" algn="ctr">
+                      <a:solidFill>
+                        <a:srgbClr val="D6DAE0"/>
+                      </a:solidFill>
+                      <a:prstDash val="solid"/>
+                      <a:round/>
+                      <a:headEnd type="none" w="med" len="med"/>
+                      <a:tailEnd type="none" w="med" len="med"/>
+                    </a:lnL>
+                    <a:lnR w="6350" cap="flat" cmpd="sng" algn="ctr">
+                      <a:solidFill>
+                        <a:srgbClr val="D6DAE0"/>
+                      </a:solidFill>
+                      <a:prstDash val="solid"/>
+                      <a:round/>
+                      <a:headEnd type="none" w="med" len="med"/>
+                      <a:tailEnd type="none" w="med" len="med"/>
+                    </a:lnR>
+                    <a:lnT w="6350" cap="flat" cmpd="sng" algn="ctr">
+                      <a:solidFill>
+                        <a:srgbClr val="D6DAE0"/>
+                      </a:solidFill>
+                      <a:prstDash val="solid"/>
+                      <a:round/>
+                      <a:headEnd type="none" w="med" len="med"/>
+                      <a:tailEnd type="none" w="med" len="med"/>
+                    </a:lnT>
+                    <a:lnB w="6350" cap="flat" cmpd="sng" algn="ctr">
+                      <a:solidFill>
+                        <a:srgbClr val="D6DAE0"/>
+                      </a:solidFill>
+                      <a:prstDash val="solid"/>
+                      <a:round/>
+                      <a:headEnd type="none" w="med" len="med"/>
+                      <a:tailEnd type="none" w="med" len="med"/>
+                    </a:lnB>
+                  </a:tcPr>
+                </a:tc>
+              </a:tr>
+              <a:tr h="365760">
+                <a:tc>
+                  <a:txBody>
+                    <a:bodyPr/>
+                    <a:lstStyle/>
+                    <a:p>
+                      <a:pPr indent="0" marL="0">
+                        <a:buNone/>
+                      </a:pPr>
+                      <a:r>
+                        <a:rPr lang="en-US" sz="1050" dirty="0">
+                          <a:solidFill>
+                            <a:srgbClr val="16181D"/>
+                          </a:solidFill>
+                          <a:latin typeface="Arial" pitchFamily="34" charset="0"/>
+                          <a:ea typeface="Arial" pitchFamily="34" charset="-122"/>
+                          <a:cs typeface="Arial" pitchFamily="34" charset="-120"/>
+                        </a:rPr>
+                        <a:t>Bare names, PIN code (documented gaps)</a:t>
+                      </a:r>
+                      <a:endParaRPr lang="en-US" sz="1050" dirty="0">
+                        <a:latin typeface="Arial" charset="0"/>
+                        <a:ea typeface="Arial" charset="0"/>
+                        <a:cs typeface="Arial" charset="0"/>
+                      </a:endParaRPr>
+                    </a:p>
+                  </a:txBody>
+                  <a:tcPr marL="91440" marR="91440" marT="45720" marB="45720" anchor="ctr">
+                    <a:lnL w="6350" cap="flat" cmpd="sng" algn="ctr">
+                      <a:solidFill>
+                        <a:srgbClr val="D6DAE0"/>
+                      </a:solidFill>
+                      <a:prstDash val="solid"/>
+                      <a:round/>
+                      <a:headEnd type="none" w="med" len="med"/>
+                      <a:tailEnd type="none" w="med" len="med"/>
+                    </a:lnL>
+                    <a:lnR w="6350" cap="flat" cmpd="sng" algn="ctr">
+                      <a:solidFill>
+                        <a:srgbClr val="D6DAE0"/>
+                      </a:solidFill>
+                      <a:prstDash val="solid"/>
+                      <a:round/>
+                      <a:headEnd type="none" w="med" len="med"/>
+                      <a:tailEnd type="none" w="med" len="med"/>
+                    </a:lnR>
+                    <a:lnT w="6350" cap="flat" cmpd="sng" algn="ctr">
+                      <a:solidFill>
+                        <a:srgbClr val="D6DAE0"/>
+                      </a:solidFill>
+                      <a:prstDash val="solid"/>
+                      <a:round/>
+                      <a:headEnd type="none" w="med" len="med"/>
+                      <a:tailEnd type="none" w="med" len="med"/>
+                    </a:lnT>
+                    <a:lnB w="6350" cap="flat" cmpd="sng" algn="ctr">
+                      <a:solidFill>
+                        <a:srgbClr val="D6DAE0"/>
+                      </a:solidFill>
+                      <a:prstDash val="solid"/>
+                      <a:round/>
+                      <a:headEnd type="none" w="med" len="med"/>
+                      <a:tailEnd type="none" w="med" len="med"/>
+                    </a:lnB>
+                  </a:tcPr>
+                </a:tc>
+                <a:tc>
+                  <a:txBody>
+                    <a:bodyPr/>
+                    <a:lstStyle/>
+                    <a:p>
+                      <a:pPr indent="0" marL="0">
+                        <a:buNone/>
+                      </a:pPr>
+                      <a:r>
+                        <a:rPr lang="en-US" sz="1050" dirty="0">
+                          <a:solidFill>
+                            <a:srgbClr val="16181D"/>
+                          </a:solidFill>
+                          <a:latin typeface="Arial" pitchFamily="34" charset="0"/>
+                          <a:ea typeface="Arial" pitchFamily="34" charset="-122"/>
+                          <a:cs typeface="Arial" pitchFamily="34" charset="-120"/>
+                        </a:rPr>
+                        <a:t>2</a:t>
+                      </a:r>
+                      <a:endParaRPr lang="en-US" sz="1050" dirty="0">
+                        <a:latin typeface="Arial" charset="0"/>
+                        <a:ea typeface="Arial" charset="0"/>
+                        <a:cs typeface="Arial" charset="0"/>
+                      </a:endParaRPr>
+                    </a:p>
+                  </a:txBody>
+                  <a:tcPr marL="91440" marR="91440" marT="45720" marB="45720" anchor="ctr">
+                    <a:lnL w="6350" cap="flat" cmpd="sng" algn="ctr">
+                      <a:solidFill>
+                        <a:srgbClr val="D6DAE0"/>
+                      </a:solidFill>
+                      <a:prstDash val="solid"/>
+                      <a:round/>
+                      <a:headEnd type="none" w="med" len="med"/>
+                      <a:tailEnd type="none" w="med" len="med"/>
+                    </a:lnL>
+                    <a:lnR w="6350" cap="flat" cmpd="sng" algn="ctr">
+                      <a:solidFill>
+                        <a:srgbClr val="D6DAE0"/>
+                      </a:solidFill>
+                      <a:prstDash val="solid"/>
+                      <a:round/>
+                      <a:headEnd type="none" w="med" len="med"/>
+                      <a:tailEnd type="none" w="med" len="med"/>
+                    </a:lnR>
+                    <a:lnT w="6350" cap="flat" cmpd="sng" algn="ctr">
+                      <a:solidFill>
+                        <a:srgbClr val="D6DAE0"/>
+                      </a:solidFill>
+                      <a:prstDash val="solid"/>
+                      <a:round/>
+                      <a:headEnd type="none" w="med" len="med"/>
+                      <a:tailEnd type="none" w="med" len="med"/>
+                    </a:lnT>
+                    <a:lnB w="6350" cap="flat" cmpd="sng" algn="ctr">
+                      <a:solidFill>
+                        <a:srgbClr val="D6DAE0"/>
+                      </a:solidFill>
+                      <a:prstDash val="solid"/>
+                      <a:round/>
+                      <a:headEnd type="none" w="med" len="med"/>
+                      <a:tailEnd type="none" w="med" len="med"/>
+                    </a:lnB>
+                  </a:tcPr>
+                </a:tc>
+                <a:tc>
+                  <a:txBody>
+                    <a:bodyPr/>
+                    <a:lstStyle/>
+                    <a:p>
+                      <a:pPr indent="0" marL="0">
+                        <a:buNone/>
+                      </a:pPr>
+                      <a:r>
+                        <a:rPr lang="en-US" sz="1050" dirty="0">
+                          <a:solidFill>
+                            <a:srgbClr val="16181D"/>
+                          </a:solidFill>
+                          <a:latin typeface="Arial" pitchFamily="34" charset="0"/>
+                          <a:ea typeface="Arial" pitchFamily="34" charset="-122"/>
+                          <a:cs typeface="Arial" pitchFamily="34" charset="-120"/>
+                        </a:rPr>
+                        <a:t>n/a</a:t>
+                      </a:r>
+                      <a:endParaRPr lang="en-US" sz="1050" dirty="0">
+                        <a:latin typeface="Arial" charset="0"/>
+                        <a:ea typeface="Arial" charset="0"/>
+                        <a:cs typeface="Arial" charset="0"/>
+                      </a:endParaRPr>
+                    </a:p>
+                  </a:txBody>
+                  <a:tcPr marL="91440" marR="91440" marT="45720" marB="45720" anchor="ctr">
+                    <a:lnL w="6350" cap="flat" cmpd="sng" algn="ctr">
+                      <a:solidFill>
+                        <a:srgbClr val="D6DAE0"/>
+                      </a:solidFill>
+                      <a:prstDash val="solid"/>
+                      <a:round/>
+                      <a:headEnd type="none" w="med" len="med"/>
+                      <a:tailEnd type="none" w="med" len="med"/>
+                    </a:lnL>
+                    <a:lnR w="6350" cap="flat" cmpd="sng" algn="ctr">
+                      <a:solidFill>
+                        <a:srgbClr val="D6DAE0"/>
+                      </a:solidFill>
+                      <a:prstDash val="solid"/>
+                      <a:round/>
+                      <a:headEnd type="none" w="med" len="med"/>
+                      <a:tailEnd type="none" w="med" len="med"/>
+                    </a:lnR>
+                    <a:lnT w="6350" cap="flat" cmpd="sng" algn="ctr">
+                      <a:solidFill>
+                        <a:srgbClr val="D6DAE0"/>
+                      </a:solidFill>
+                      <a:prstDash val="solid"/>
+                      <a:round/>
+                      <a:headEnd type="none" w="med" len="med"/>
+                      <a:tailEnd type="none" w="med" len="med"/>
+                    </a:lnT>
+                    <a:lnB w="6350" cap="flat" cmpd="sng" algn="ctr">
+                      <a:solidFill>
+                        <a:srgbClr val="D6DAE0"/>
+                      </a:solidFill>
+                      <a:prstDash val="solid"/>
+                      <a:round/>
+                      <a:headEnd type="none" w="med" len="med"/>
+                      <a:tailEnd type="none" w="med" len="med"/>
+                    </a:lnB>
+                  </a:tcPr>
+                </a:tc>
+                <a:tc>
+                  <a:txBody>
+                    <a:bodyPr/>
+                    <a:lstStyle/>
+                    <a:p>
+                      <a:pPr indent="0" marL="0">
+                        <a:buNone/>
+                      </a:pPr>
+                      <a:r>
+                        <a:rPr lang="en-US" sz="1050" dirty="0">
+                          <a:solidFill>
+                            <a:srgbClr val="16181D"/>
+                          </a:solidFill>
+                          <a:latin typeface="Arial" pitchFamily="34" charset="0"/>
+                          <a:ea typeface="Arial" pitchFamily="34" charset="-122"/>
+                          <a:cs typeface="Arial" pitchFamily="34" charset="-120"/>
+                        </a:rPr>
+                        <a:t>0%</a:t>
+                      </a:r>
+                      <a:endParaRPr lang="en-US" sz="1050" dirty="0">
+                        <a:latin typeface="Arial" charset="0"/>
+                        <a:ea typeface="Arial" charset="0"/>
+                        <a:cs typeface="Arial" charset="0"/>
+                      </a:endParaRPr>
+                    </a:p>
+                  </a:txBody>
+                  <a:tcPr marL="91440" marR="91440" marT="45720" marB="45720" anchor="ctr">
+                    <a:lnL w="6350" cap="flat" cmpd="sng" algn="ctr">
+                      <a:solidFill>
+                        <a:srgbClr val="D6DAE0"/>
+                      </a:solidFill>
+                      <a:prstDash val="solid"/>
+                      <a:round/>
+                      <a:headEnd type="none" w="med" len="med"/>
+                      <a:tailEnd type="none" w="med" len="med"/>
+                    </a:lnL>
+                    <a:lnR w="6350" cap="flat" cmpd="sng" algn="ctr">
+                      <a:solidFill>
+                        <a:srgbClr val="D6DAE0"/>
+                      </a:solidFill>
+                      <a:prstDash val="solid"/>
+                      <a:round/>
+                      <a:headEnd type="none" w="med" len="med"/>
+                      <a:tailEnd type="none" w="med" len="med"/>
+                    </a:lnR>
+                    <a:lnT w="6350" cap="flat" cmpd="sng" algn="ctr">
+                      <a:solidFill>
+                        <a:srgbClr val="D6DAE0"/>
+                      </a:solidFill>
+                      <a:prstDash val="solid"/>
+                      <a:round/>
+                      <a:headEnd type="none" w="med" len="med"/>
+                      <a:tailEnd type="none" w="med" len="med"/>
+                    </a:lnT>
+                    <a:lnB w="6350" cap="flat" cmpd="sng" algn="ctr">
+                      <a:solidFill>
+                        <a:srgbClr val="D6DAE0"/>
+                      </a:solidFill>
+                      <a:prstDash val="solid"/>
+                      <a:round/>
+                      <a:headEnd type="none" w="med" len="med"/>
+                      <a:tailEnd type="none" w="med" len="med"/>
+                    </a:lnB>
+                  </a:tcPr>
+                </a:tc>
+              </a:tr>
+              <a:tr h="365760">
+                <a:tc>
+                  <a:txBody>
+                    <a:bodyPr/>
+                    <a:lstStyle/>
+                    <a:p>
+                      <a:pPr indent="0" marL="0">
+                        <a:buNone/>
+                      </a:pPr>
+                      <a:r>
+                        <a:rPr lang="en-US" sz="1050" b="1" dirty="0">
+                          <a:solidFill>
+                            <a:srgbClr val="16181D"/>
+                          </a:solidFill>
+                          <a:latin typeface="Arial" pitchFamily="34" charset="0"/>
+                          <a:ea typeface="Arial" pitchFamily="34" charset="-122"/>
+                          <a:cs typeface="Arial" pitchFamily="34" charset="-120"/>
+                        </a:rPr>
+                        <a:t>micro average</a:t>
+                      </a:r>
+                      <a:endParaRPr lang="en-US" sz="1050" dirty="0">
+                        <a:latin typeface="Arial" charset="0"/>
+                        <a:ea typeface="Arial" charset="0"/>
+                        <a:cs typeface="Arial" charset="0"/>
+                      </a:endParaRPr>
+                    </a:p>
+                  </a:txBody>
+                  <a:tcPr marL="91440" marR="91440" marT="45720" marB="45720" anchor="ctr">
+                    <a:lnL w="6350" cap="flat" cmpd="sng" algn="ctr">
+                      <a:solidFill>
+                        <a:srgbClr val="D6DAE0"/>
+                      </a:solidFill>
+                      <a:prstDash val="solid"/>
+                      <a:round/>
+                      <a:headEnd type="none" w="med" len="med"/>
+                      <a:tailEnd type="none" w="med" len="med"/>
+                    </a:lnL>
+                    <a:lnR w="6350" cap="flat" cmpd="sng" algn="ctr">
+                      <a:solidFill>
+                        <a:srgbClr val="D6DAE0"/>
+                      </a:solidFill>
+                      <a:prstDash val="solid"/>
+                      <a:round/>
+                      <a:headEnd type="none" w="med" len="med"/>
+                      <a:tailEnd type="none" w="med" len="med"/>
+                    </a:lnR>
+                    <a:lnT w="6350" cap="flat" cmpd="sng" algn="ctr">
+                      <a:solidFill>
+                        <a:srgbClr val="D6DAE0"/>
+                      </a:solidFill>
+                      <a:prstDash val="solid"/>
+                      <a:round/>
+                      <a:headEnd type="none" w="med" len="med"/>
+                      <a:tailEnd type="none" w="med" len="med"/>
+                    </a:lnT>
+                    <a:lnB w="6350" cap="flat" cmpd="sng" algn="ctr">
+                      <a:solidFill>
+                        <a:srgbClr val="D6DAE0"/>
+                      </a:solidFill>
+                      <a:prstDash val="solid"/>
+                      <a:round/>
+                      <a:headEnd type="none" w="med" len="med"/>
+                      <a:tailEnd type="none" w="med" len="med"/>
+                    </a:lnB>
+                  </a:tcPr>
+                </a:tc>
+                <a:tc>
+                  <a:txBody>
+                    <a:bodyPr/>
+                    <a:lstStyle/>
+                    <a:p>
+                      <a:pPr indent="0" marL="0">
+                        <a:buNone/>
+                      </a:pPr>
+                      <a:r>
+                        <a:rPr lang="en-US" sz="1050" b="1" dirty="0">
+                          <a:solidFill>
+                            <a:srgbClr val="16181D"/>
+                          </a:solidFill>
+                          <a:latin typeface="Arial" pitchFamily="34" charset="0"/>
+                          <a:ea typeface="Arial" pitchFamily="34" charset="-122"/>
+                          <a:cs typeface="Arial" pitchFamily="34" charset="-120"/>
+                        </a:rPr>
+                        <a:t>35</a:t>
+                      </a:r>
+                      <a:endParaRPr lang="en-US" sz="1050" dirty="0">
+                        <a:latin typeface="Arial" charset="0"/>
+                        <a:ea typeface="Arial" charset="0"/>
+                        <a:cs typeface="Arial" charset="0"/>
+                      </a:endParaRPr>
+                    </a:p>
+                  </a:txBody>
+                  <a:tcPr marL="91440" marR="91440" marT="45720" marB="45720" anchor="ctr">
+                    <a:lnL w="6350" cap="flat" cmpd="sng" algn="ctr">
+                      <a:solidFill>
+                        <a:srgbClr val="D6DAE0"/>
+                      </a:solidFill>
+                      <a:prstDash val="solid"/>
+                      <a:round/>
+                      <a:headEnd type="none" w="med" len="med"/>
+                      <a:tailEnd type="none" w="med" len="med"/>
+                    </a:lnL>
+                    <a:lnR w="6350" cap="flat" cmpd="sng" algn="ctr">
+                      <a:solidFill>
+                        <a:srgbClr val="D6DAE0"/>
+                      </a:solidFill>
+                      <a:prstDash val="solid"/>
+                      <a:round/>
+                      <a:headEnd type="none" w="med" len="med"/>
+                      <a:tailEnd type="none" w="med" len="med"/>
+                    </a:lnR>
+                    <a:lnT w="6350" cap="flat" cmpd="sng" algn="ctr">
+                      <a:solidFill>
+                        <a:srgbClr val="D6DAE0"/>
+                      </a:solidFill>
+                      <a:prstDash val="solid"/>
+                      <a:round/>
+                      <a:headEnd type="none" w="med" len="med"/>
+                      <a:tailEnd type="none" w="med" len="med"/>
+                    </a:lnT>
+                    <a:lnB w="6350" cap="flat" cmpd="sng" algn="ctr">
+                      <a:solidFill>
+                        <a:srgbClr val="D6DAE0"/>
+                      </a:solidFill>
+                      <a:prstDash val="solid"/>
+                      <a:round/>
+                      <a:headEnd type="none" w="med" len="med"/>
+                      <a:tailEnd type="none" w="med" len="med"/>
+                    </a:lnB>
+                  </a:tcPr>
+                </a:tc>
+                <a:tc>
+                  <a:txBody>
+                    <a:bodyPr/>
+                    <a:lstStyle/>
+                    <a:p>
+                      <a:pPr indent="0" marL="0">
+                        <a:buNone/>
+                      </a:pPr>
+                      <a:r>
+                        <a:rPr lang="en-US" sz="1050" b="1" dirty="0">
+                          <a:solidFill>
+                            <a:srgbClr val="3D5A3D"/>
+                          </a:solidFill>
+                          <a:latin typeface="Arial" pitchFamily="34" charset="0"/>
+                          <a:ea typeface="Arial" pitchFamily="34" charset="-122"/>
+                          <a:cs typeface="Arial" pitchFamily="34" charset="-120"/>
+                        </a:rPr>
+                        <a:t>100%</a:t>
+                      </a:r>
+                      <a:endParaRPr lang="en-US" sz="1050" dirty="0">
+                        <a:latin typeface="Arial" charset="0"/>
+                        <a:ea typeface="Arial" charset="0"/>
+                        <a:cs typeface="Arial" charset="0"/>
+                      </a:endParaRPr>
+                    </a:p>
+                  </a:txBody>
+                  <a:tcPr marL="91440" marR="91440" marT="45720" marB="45720" anchor="ctr">
+                    <a:lnL w="6350" cap="flat" cmpd="sng" algn="ctr">
+                      <a:solidFill>
+                        <a:srgbClr val="D6DAE0"/>
+                      </a:solidFill>
+                      <a:prstDash val="solid"/>
+                      <a:round/>
+                      <a:headEnd type="none" w="med" len="med"/>
+                      <a:tailEnd type="none" w="med" len="med"/>
+                    </a:lnL>
+                    <a:lnR w="6350" cap="flat" cmpd="sng" algn="ctr">
+                      <a:solidFill>
+                        <a:srgbClr val="D6DAE0"/>
+                      </a:solidFill>
+                      <a:prstDash val="solid"/>
+                      <a:round/>
+                      <a:headEnd type="none" w="med" len="med"/>
+                      <a:tailEnd type="none" w="med" len="med"/>
+                    </a:lnR>
+                    <a:lnT w="6350" cap="flat" cmpd="sng" algn="ctr">
+                      <a:solidFill>
+                        <a:srgbClr val="D6DAE0"/>
+                      </a:solidFill>
+                      <a:prstDash val="solid"/>
+                      <a:round/>
+                      <a:headEnd type="none" w="med" len="med"/>
+                      <a:tailEnd type="none" w="med" len="med"/>
+                    </a:lnT>
+                    <a:lnB w="6350" cap="flat" cmpd="sng" algn="ctr">
+                      <a:solidFill>
+                        <a:srgbClr val="D6DAE0"/>
+                      </a:solidFill>
+                      <a:prstDash val="solid"/>
+                      <a:round/>
+                      <a:headEnd type="none" w="med" len="med"/>
+                      <a:tailEnd type="none" w="med" len="med"/>
+                    </a:lnB>
+                  </a:tcPr>
+                </a:tc>
+                <a:tc>
+                  <a:txBody>
+                    <a:bodyPr/>
+                    <a:lstStyle/>
+                    <a:p>
+                      <a:pPr indent="0" marL="0">
+                        <a:buNone/>
+                      </a:pPr>
+                      <a:r>
+                        <a:rPr lang="en-US" sz="1050" b="1" dirty="0">
+                          <a:solidFill>
+                            <a:srgbClr val="16181D"/>
+                          </a:solidFill>
+                          <a:latin typeface="Arial" pitchFamily="34" charset="0"/>
+                          <a:ea typeface="Arial" pitchFamily="34" charset="-122"/>
+                          <a:cs typeface="Arial" pitchFamily="34" charset="-120"/>
+                        </a:rPr>
+                        <a:t>91.4%</a:t>
+                      </a:r>
+                      <a:endParaRPr lang="en-US" sz="1050" dirty="0">
+                        <a:latin typeface="Arial" charset="0"/>
+                        <a:ea typeface="Arial" charset="0"/>
+                        <a:cs typeface="Arial" charset="0"/>
+                      </a:endParaRPr>
+                    </a:p>
+                  </a:txBody>
+                  <a:tcPr marL="91440" marR="91440" marT="45720" marB="45720" anchor="ctr">
+                    <a:lnL w="6350" cap="flat" cmpd="sng" algn="ctr">
+                      <a:solidFill>
+                        <a:srgbClr val="D6DAE0"/>
+                      </a:solidFill>
+                      <a:prstDash val="solid"/>
+                      <a:round/>
+                      <a:headEnd type="none" w="med" len="med"/>
+                      <a:tailEnd type="none" w="med" len="med"/>
+                    </a:lnL>
+                    <a:lnR w="6350" cap="flat" cmpd="sng" algn="ctr">
+                      <a:solidFill>
+                        <a:srgbClr val="D6DAE0"/>
+                      </a:solidFill>
+                      <a:prstDash val="solid"/>
+                      <a:round/>
+                      <a:headEnd type="none" w="med" len="med"/>
+                      <a:tailEnd type="none" w="med" len="med"/>
+                    </a:lnR>
+                    <a:lnT w="6350" cap="flat" cmpd="sng" algn="ctr">
+                      <a:solidFill>
+                        <a:srgbClr val="D6DAE0"/>
+                      </a:solidFill>
+                      <a:prstDash val="solid"/>
+                      <a:round/>
+                      <a:headEnd type="none" w="med" len="med"/>
+                      <a:tailEnd type="none" w="med" len="med"/>
+                    </a:lnT>
+                    <a:lnB w="6350" cap="flat" cmpd="sng" algn="ctr">
+                      <a:solidFill>
+                        <a:srgbClr val="D6DAE0"/>
+                      </a:solidFill>
+                      <a:prstDash val="solid"/>
+                      <a:round/>
+                      <a:headEnd type="none" w="med" len="med"/>
+                      <a:tailEnd type="none" w="med" len="med"/>
+                    </a:lnB>
+                  </a:tcPr>
+                </a:tc>
               </a:tr>
             </a:tbl>
           </a:graphicData>
@@ -6706,14 +8633,14 @@
       </p:graphicFrame>
       <p:sp>
         <p:nvSpPr>
-          <p:cNvPr id="5" name="Text 2"/>
+          <p:cNvPr id="21" name="Text 18"/>
           <p:cNvSpPr/>
           <p:nvPr/>
         </p:nvSpPr>
         <p:spPr>
           <a:xfrm>
-            <a:off x="502920" y="3200400"/>
-            <a:ext cx="11155680" cy="4937760"/>
+            <a:off x="502920" y="6035040"/>
+            <a:ext cx="5760720" cy="685800"/>
           </a:xfrm>
           <a:prstGeom prst="rect">
             <a:avLst/>
@@ -6722,115 +8649,51 @@
           <a:ln/>
         </p:spPr>
         <p:txBody>
-          <a:bodyPr wrap="square" rtlCol="0" anchor="t"/>
+          <a:bodyPr wrap="square" rtlCol="0" anchor="ctr"/>
           <a:lstStyle/>
           <a:p>
-            <a:pPr marL="152400" indent="-152400">
-              <a:lnSpc>
-                <a:spcPct val="118000"/>
-              </a:lnSpc>
-              <a:buSzPct val="100000"/>
-              <a:buChar char="•"/>
+            <a:pPr indent="0" marL="0">
+              <a:buNone/>
             </a:pPr>
             <a:r>
-              <a:rPr lang="en-US" sz="1250" dirty="0">
-                <a:solidFill>
-                  <a:srgbClr val="16181D"/>
+              <a:rPr lang="en-US" sz="950" i="1" dirty="0">
+                <a:solidFill>
+                  <a:srgbClr val="5A6470"/>
                 </a:solidFill>
                 <a:latin typeface="Arial" pitchFamily="34" charset="0"/>
                 <a:ea typeface="Arial" pitchFamily="34" charset="-122"/>
                 <a:cs typeface="Arial" pitchFamily="34" charset="-120"/>
               </a:rPr>
-              <a:t>12-slice corpus: government, banking, payments, mail, commerce, social, healthcare, enterprise, hard cases. Synthetic personas only; UIDAI test ranges for Aadhaar.</a:t>
-            </a:r>
-            <a:endParaRPr lang="en-US" sz="1250" dirty="0"/>
-          </a:p>
-          <a:p>
-            <a:pPr marL="152400" indent="-152400">
-              <a:lnSpc>
-                <a:spcPct val="118000"/>
-              </a:lnSpc>
-              <a:buSzPct val="100000"/>
-              <a:buChar char="•"/>
-            </a:pPr>
-            <a:r>
-              <a:rPr lang="en-US" sz="1250" dirty="0">
-                <a:solidFill>
-                  <a:srgbClr val="16181D"/>
-                </a:solidFill>
-                <a:latin typeface="Arial" pitchFamily="34" charset="0"/>
-                <a:ea typeface="Arial" pitchFamily="34" charset="-122"/>
-                <a:cs typeface="Arial" pitchFamily="34" charset="-120"/>
-              </a:rPr>
-              <a:t>Declared negatives make precision real: order IDs, toll-free helplines, appointment dates and employee IDs must NOT be masked, and are not.</a:t>
-            </a:r>
-            <a:endParaRPr lang="en-US" sz="1250" dirty="0"/>
-          </a:p>
-          <a:p>
-            <a:pPr marL="152400" indent="-152400">
-              <a:lnSpc>
-                <a:spcPct val="118000"/>
-              </a:lnSpc>
-              <a:buSzPct val="100000"/>
-              <a:buChar char="•"/>
-            </a:pPr>
-            <a:r>
-              <a:rPr lang="en-US" sz="1250" b="1" dirty="0">
-                <a:solidFill>
-                  <a:srgbClr val="16181D"/>
-                </a:solidFill>
-                <a:latin typeface="Arial" pitchFamily="34" charset="0"/>
-                <a:ea typeface="Arial" pitchFamily="34" charset="-122"/>
-                <a:cs typeface="Arial" pitchFamily="34" charset="-120"/>
-              </a:rPr>
-              <a:t>Checksum-validated classes (Aadhaar, PAN, GSTIN, cards, IFSC): 100% precision and recall.</a:t>
-            </a:r>
-            <a:endParaRPr lang="en-US" sz="1250" dirty="0"/>
-          </a:p>
-          <a:p>
-            <a:pPr marL="152400" indent="-152400">
-              <a:lnSpc>
-                <a:spcPct val="118000"/>
-              </a:lnSpc>
-              <a:buSzPct val="100000"/>
-              <a:buChar char="•"/>
-            </a:pPr>
-            <a:r>
-              <a:rPr lang="en-US" sz="1250" dirty="0">
-                <a:solidFill>
-                  <a:srgbClr val="16181D"/>
-                </a:solidFill>
-                <a:latin typeface="Arial" pitchFamily="34" charset="0"/>
-                <a:ea typeface="Arial" pitchFamily="34" charset="-122"/>
-                <a:cs typeface="Arial" pitchFamily="34" charset="-120"/>
-              </a:rPr>
-              <a:t>Known gaps are published, not hidden: free-text addresses and bare names await the NER tier. A CI test asserts the gap list is exactly that, so nothing regresses silently.</a:t>
-            </a:r>
-            <a:endParaRPr lang="en-US" sz="1250" dirty="0"/>
-          </a:p>
-          <a:p>
-            <a:pPr lvl="1" marL="254000" indent="-127000">
-              <a:lnSpc>
-                <a:spcPct val="118000"/>
-              </a:lnSpc>
-              <a:buSzPct val="100000"/>
-              <a:buChar char="–"/>
-            </a:pPr>
-            <a:r>
-              <a:rPr lang="en-US" sz="1200" dirty="0">
-                <a:solidFill>
-                  <a:srgbClr val="5A6470"/>
-                </a:solidFill>
-                <a:latin typeface="Arial" pitchFamily="34" charset="0"/>
-                <a:ea typeface="Arial" pitchFamily="34" charset="-122"/>
-                <a:cs typeface="Arial" pitchFamily="34" charset="-120"/>
-              </a:rPr>
-              <a:t>Reproduce: npm run bench</a:t>
-            </a:r>
-            <a:endParaRPr lang="en-US" sz="1250" dirty="0"/>
+              <a:t>Fortress mode: recall 94.3% (catches the PIN code) at the cost of one bounded false alarm. Negatives (order ids, helplines, appointment dates) must NOT be masked, and are not. Reproduce: npm run bench</a:t>
+            </a:r>
+            <a:endParaRPr lang="en-US" sz="950" dirty="0"/>
           </a:p>
         </p:txBody>
       </p:sp>
+      <p:pic>
+        <p:nvPicPr>
+          <p:cNvPr id="22" name="Image 0" descr="/Users/bhoomi/workspace/SIH 2026/browser-vision-agent/tools/deck/assets/chart-latency.png">    </p:cNvPr>
+          <p:cNvPicPr>
+            <a:picLocks noChangeAspect="1"/>
+          </p:cNvPicPr>
+          <p:nvPr/>
+        </p:nvPicPr>
+        <p:blipFill>
+          <a:blip r:embed="rId1"/>
+          <a:stretch>
+            <a:fillRect/>
+          </a:stretch>
+        </p:blipFill>
+        <p:spPr>
+          <a:xfrm>
+            <a:off x="6446520" y="2152864"/>
+            <a:ext cx="5257800" cy="4198192"/>
+          </a:xfrm>
+          <a:prstGeom prst="rect">
+            <a:avLst/>
+          </a:prstGeom>
+        </p:spPr>
+      </p:pic>
       <p:sp>
         <p:nvSpPr>
           <p:cNvPr id="25" name="Slide Number Placeholder 0"/>
@@ -6937,7 +8800,7 @@
                 <a:ea typeface="Arial" pitchFamily="34" charset="-122"/>
                 <a:cs typeface="Arial" pitchFamily="34" charset="-120"/>
               </a:rPr>
-              <a:t>FAST ENOUGH TO DISAPPEAR</a:t>
+              <a:t>THE BENCHMARK, CONTINUED</a:t>
             </a:r>
             <a:endParaRPr lang="en-US" sz="1100" dirty="0"/>
           </a:p>
@@ -6976,9 +8839,72 @@
                 <a:ea typeface="Arial" pitchFamily="34" charset="-122"/>
                 <a:cs typeface="Arial" pitchFamily="34" charset="-120"/>
               </a:rPr>
-              <a:t>Local pipeline: 16 ms measured against a 175 ms budget</a:t>
+              <a:t>Recall per class, and what the numbers protect</a:t>
             </a:r>
             <a:endParaRPr lang="en-US" sz="2600" dirty="0"/>
+          </a:p>
+        </p:txBody>
+      </p:sp>
+      <p:pic>
+        <p:nvPicPr>
+          <p:cNvPr id="4" name="Image 0" descr="/Users/bhoomi/workspace/SIH 2026/browser-vision-agent/tools/deck/assets/chart-recall.png">    </p:cNvPr>
+          <p:cNvPicPr>
+            <a:picLocks noChangeAspect="1"/>
+          </p:cNvPicPr>
+          <p:nvPr/>
+        </p:nvPicPr>
+        <p:blipFill>
+          <a:blip r:embed="rId1"/>
+          <a:stretch>
+            <a:fillRect/>
+          </a:stretch>
+        </p:blipFill>
+        <p:spPr>
+          <a:xfrm>
+            <a:off x="542962" y="1188720"/>
+            <a:ext cx="5680636" cy="5212080"/>
+          </a:xfrm>
+          <a:prstGeom prst="rect">
+            <a:avLst/>
+          </a:prstGeom>
+        </p:spPr>
+      </p:pic>
+      <p:sp>
+        <p:nvSpPr>
+          <p:cNvPr id="5" name="Text 2"/>
+          <p:cNvSpPr/>
+          <p:nvPr/>
+        </p:nvSpPr>
+        <p:spPr>
+          <a:xfrm>
+            <a:off x="6629400" y="1325880"/>
+            <a:ext cx="5029200" cy="274320"/>
+          </a:xfrm>
+          <a:prstGeom prst="rect">
+            <a:avLst/>
+          </a:prstGeom>
+          <a:noFill/>
+          <a:ln/>
+        </p:spPr>
+        <p:txBody>
+          <a:bodyPr wrap="square" rtlCol="0" anchor="ctr"/>
+          <a:lstStyle/>
+          <a:p>
+            <a:pPr indent="0" marL="0">
+              <a:buNone/>
+            </a:pPr>
+            <a:r>
+              <a:rPr lang="en-US" sz="1200" b="1" dirty="0">
+                <a:solidFill>
+                  <a:srgbClr val="1F4E79"/>
+                </a:solidFill>
+                <a:latin typeface="Arial" pitchFamily="34" charset="0"/>
+                <a:ea typeface="Arial" pitchFamily="34" charset="-122"/>
+                <a:cs typeface="Arial" pitchFamily="34" charset="-120"/>
+              </a:rPr>
+              <a:t>Blur-recovery attack (metric: redaction precision)</a:t>
+            </a:r>
+            <a:endParaRPr lang="en-US" sz="1200" dirty="0"/>
           </a:p>
         </p:txBody>
       </p:sp>
@@ -6997,19 +8923,19 @@
           </p:nvPr>
         </p:nvGraphicFramePr>
         <p:xfrm>
-          <a:off x="502920" y="1371600"/>
-          <a:ext cx="7498080" cy="914400"/>
+          <a:off x="6629400" y="1645920"/>
+          <a:ext cx="5029200" cy="914400"/>
         </p:xfrm>
         <a:graphic>
           <a:graphicData uri="http://schemas.openxmlformats.org/drawingml/2006/table">
             <a:tbl>
               <a:tblPr/>
               <a:tblGrid>
-                <a:gridCol w="5120640"/>
-                <a:gridCol w="1188720"/>
-                <a:gridCol w="1188720"/>
+                <a:gridCol w="1920240"/>
+                <a:gridCol w="1737360"/>
+                <a:gridCol w="1371600"/>
               </a:tblGrid>
-              <a:tr h="411480">
+              <a:tr h="384048">
                 <a:tc>
                   <a:txBody>
                     <a:bodyPr/>
@@ -7027,7 +8953,7 @@
                           <a:ea typeface="Arial" pitchFamily="34" charset="-122"/>
                           <a:cs typeface="Arial" pitchFamily="34" charset="-120"/>
                         </a:rPr>
-                        <a:t>Stage (real code paths)</a:t>
+                        <a:t>Redaction</a:t>
                       </a:r>
                       <a:endParaRPr lang="en-US" sz="1100" dirty="0">
                         <a:latin typeface="Arial" charset="0"/>
@@ -7095,7 +9021,7 @@
                           <a:ea typeface="Arial" pitchFamily="34" charset="-122"/>
                           <a:cs typeface="Arial" pitchFamily="34" charset="-120"/>
                         </a:rPr>
-                        <a:t>p50</a:t>
+                        <a:t>Digits recovered</a:t>
                       </a:r>
                       <a:endParaRPr lang="en-US" sz="1100" dirty="0">
                         <a:latin typeface="Arial" charset="0"/>
@@ -7163,7 +9089,7 @@
                           <a:ea typeface="Arial" pitchFamily="34" charset="-122"/>
                           <a:cs typeface="Arial" pitchFamily="34" charset="-120"/>
                         </a:rPr>
-                        <a:t>p95</a:t>
+                        <a:t>Signal</a:t>
                       </a:r>
                       <a:endParaRPr lang="en-US" sz="1100" dirty="0">
                         <a:latin typeface="Arial" charset="0"/>
@@ -7215,7 +9141,7 @@
                   </a:tcPr>
                 </a:tc>
               </a:tr>
-              <a:tr h="411480">
+              <a:tr h="384048">
                 <a:tc>
                   <a:txBody>
                     <a:bodyPr/>
@@ -7233,7 +9159,72 @@
                           <a:ea typeface="Arial" pitchFamily="34" charset="-122"/>
                           <a:cs typeface="Arial" pitchFamily="34" charset="-120"/>
                         </a:rPr>
-                        <a:t>Policy engine (full 12-capture corpus)</a:t>
+                        <a:t>Gaussian blur (sigma 14)</a:t>
+                      </a:r>
+                      <a:endParaRPr lang="en-US" sz="1050" dirty="0">
+                        <a:latin typeface="Arial" charset="0"/>
+                        <a:ea typeface="Arial" charset="0"/>
+                        <a:cs typeface="Arial" charset="0"/>
+                      </a:endParaRPr>
+                    </a:p>
+                  </a:txBody>
+                  <a:tcPr marL="91440" marR="91440" marT="45720" marB="45720" anchor="ctr">
+                    <a:lnL w="6350" cap="flat" cmpd="sng" algn="ctr">
+                      <a:solidFill>
+                        <a:srgbClr val="D6DAE0"/>
+                      </a:solidFill>
+                      <a:prstDash val="solid"/>
+                      <a:round/>
+                      <a:headEnd type="none" w="med" len="med"/>
+                      <a:tailEnd type="none" w="med" len="med"/>
+                    </a:lnL>
+                    <a:lnR w="6350" cap="flat" cmpd="sng" algn="ctr">
+                      <a:solidFill>
+                        <a:srgbClr val="D6DAE0"/>
+                      </a:solidFill>
+                      <a:prstDash val="solid"/>
+                      <a:round/>
+                      <a:headEnd type="none" w="med" len="med"/>
+                      <a:tailEnd type="none" w="med" len="med"/>
+                    </a:lnR>
+                    <a:lnT w="6350" cap="flat" cmpd="sng" algn="ctr">
+                      <a:solidFill>
+                        <a:srgbClr val="D6DAE0"/>
+                      </a:solidFill>
+                      <a:prstDash val="solid"/>
+                      <a:round/>
+                      <a:headEnd type="none" w="med" len="med"/>
+                      <a:tailEnd type="none" w="med" len="med"/>
+                    </a:lnT>
+                    <a:lnB w="6350" cap="flat" cmpd="sng" algn="ctr">
+                      <a:solidFill>
+                        <a:srgbClr val="D6DAE0"/>
+                      </a:solidFill>
+                      <a:prstDash val="solid"/>
+                      <a:round/>
+                      <a:headEnd type="none" w="med" len="med"/>
+                      <a:tailEnd type="none" w="med" len="med"/>
+                    </a:lnB>
+                  </a:tcPr>
+                </a:tc>
+                <a:tc>
+                  <a:txBody>
+                    <a:bodyPr/>
+                    <a:lstStyle/>
+                    <a:p>
+                      <a:pPr indent="0" marL="0">
+                        <a:buNone/>
+                      </a:pPr>
+                      <a:r>
+                        <a:rPr lang="en-US" sz="1050" b="1" dirty="0">
+                          <a:solidFill>
+                            <a:srgbClr val="7B2D26"/>
+                          </a:solidFill>
+                          <a:latin typeface="Arial" pitchFamily="34" charset="0"/>
+                          <a:ea typeface="Arial" pitchFamily="34" charset="-122"/>
+                          <a:cs typeface="Arial" pitchFamily="34" charset="-120"/>
+                        </a:rPr>
+                        <a:t>16 / 16 (100%)</a:t>
                       </a:r>
                       <a:endParaRPr lang="en-US" sz="1050" dirty="0">
                         <a:latin typeface="Arial" charset="0"/>
@@ -7298,7 +9289,139 @@
                           <a:ea typeface="Arial" pitchFamily="34" charset="-122"/>
                           <a:cs typeface="Arial" pitchFamily="34" charset="-120"/>
                         </a:rPr>
-                        <a:t>0.32 ms</a:t>
+                        <a:t>fully recoverable</a:t>
+                      </a:r>
+                      <a:endParaRPr lang="en-US" sz="1050" dirty="0">
+                        <a:latin typeface="Arial" charset="0"/>
+                        <a:ea typeface="Arial" charset="0"/>
+                        <a:cs typeface="Arial" charset="0"/>
+                      </a:endParaRPr>
+                    </a:p>
+                  </a:txBody>
+                  <a:tcPr marL="91440" marR="91440" marT="45720" marB="45720" anchor="ctr">
+                    <a:lnL w="6350" cap="flat" cmpd="sng" algn="ctr">
+                      <a:solidFill>
+                        <a:srgbClr val="D6DAE0"/>
+                      </a:solidFill>
+                      <a:prstDash val="solid"/>
+                      <a:round/>
+                      <a:headEnd type="none" w="med" len="med"/>
+                      <a:tailEnd type="none" w="med" len="med"/>
+                    </a:lnL>
+                    <a:lnR w="6350" cap="flat" cmpd="sng" algn="ctr">
+                      <a:solidFill>
+                        <a:srgbClr val="D6DAE0"/>
+                      </a:solidFill>
+                      <a:prstDash val="solid"/>
+                      <a:round/>
+                      <a:headEnd type="none" w="med" len="med"/>
+                      <a:tailEnd type="none" w="med" len="med"/>
+                    </a:lnR>
+                    <a:lnT w="6350" cap="flat" cmpd="sng" algn="ctr">
+                      <a:solidFill>
+                        <a:srgbClr val="D6DAE0"/>
+                      </a:solidFill>
+                      <a:prstDash val="solid"/>
+                      <a:round/>
+                      <a:headEnd type="none" w="med" len="med"/>
+                      <a:tailEnd type="none" w="med" len="med"/>
+                    </a:lnT>
+                    <a:lnB w="6350" cap="flat" cmpd="sng" algn="ctr">
+                      <a:solidFill>
+                        <a:srgbClr val="D6DAE0"/>
+                      </a:solidFill>
+                      <a:prstDash val="solid"/>
+                      <a:round/>
+                      <a:headEnd type="none" w="med" len="med"/>
+                      <a:tailEnd type="none" w="med" len="med"/>
+                    </a:lnB>
+                  </a:tcPr>
+                </a:tc>
+              </a:tr>
+              <a:tr h="384048">
+                <a:tc>
+                  <a:txBody>
+                    <a:bodyPr/>
+                    <a:lstStyle/>
+                    <a:p>
+                      <a:pPr indent="0" marL="0">
+                        <a:buNone/>
+                      </a:pPr>
+                      <a:r>
+                        <a:rPr lang="en-US" sz="1050" dirty="0">
+                          <a:solidFill>
+                            <a:srgbClr val="16181D"/>
+                          </a:solidFill>
+                          <a:latin typeface="Arial" pitchFamily="34" charset="0"/>
+                          <a:ea typeface="Arial" pitchFamily="34" charset="-122"/>
+                          <a:cs typeface="Arial" pitchFamily="34" charset="-120"/>
+                        </a:rPr>
+                        <a:t>Kavach flat fill</a:t>
+                      </a:r>
+                      <a:endParaRPr lang="en-US" sz="1050" dirty="0">
+                        <a:latin typeface="Arial" charset="0"/>
+                        <a:ea typeface="Arial" charset="0"/>
+                        <a:cs typeface="Arial" charset="0"/>
+                      </a:endParaRPr>
+                    </a:p>
+                  </a:txBody>
+                  <a:tcPr marL="91440" marR="91440" marT="45720" marB="45720" anchor="ctr">
+                    <a:lnL w="6350" cap="flat" cmpd="sng" algn="ctr">
+                      <a:solidFill>
+                        <a:srgbClr val="D6DAE0"/>
+                      </a:solidFill>
+                      <a:prstDash val="solid"/>
+                      <a:round/>
+                      <a:headEnd type="none" w="med" len="med"/>
+                      <a:tailEnd type="none" w="med" len="med"/>
+                    </a:lnL>
+                    <a:lnR w="6350" cap="flat" cmpd="sng" algn="ctr">
+                      <a:solidFill>
+                        <a:srgbClr val="D6DAE0"/>
+                      </a:solidFill>
+                      <a:prstDash val="solid"/>
+                      <a:round/>
+                      <a:headEnd type="none" w="med" len="med"/>
+                      <a:tailEnd type="none" w="med" len="med"/>
+                    </a:lnR>
+                    <a:lnT w="6350" cap="flat" cmpd="sng" algn="ctr">
+                      <a:solidFill>
+                        <a:srgbClr val="D6DAE0"/>
+                      </a:solidFill>
+                      <a:prstDash val="solid"/>
+                      <a:round/>
+                      <a:headEnd type="none" w="med" len="med"/>
+                      <a:tailEnd type="none" w="med" len="med"/>
+                    </a:lnT>
+                    <a:lnB w="6350" cap="flat" cmpd="sng" algn="ctr">
+                      <a:solidFill>
+                        <a:srgbClr val="D6DAE0"/>
+                      </a:solidFill>
+                      <a:prstDash val="solid"/>
+                      <a:round/>
+                      <a:headEnd type="none" w="med" len="med"/>
+                      <a:tailEnd type="none" w="med" len="med"/>
+                    </a:lnB>
+                  </a:tcPr>
+                </a:tc>
+                <a:tc>
+                  <a:txBody>
+                    <a:bodyPr/>
+                    <a:lstStyle/>
+                    <a:p>
+                      <a:pPr indent="0" marL="0">
+                        <a:buNone/>
+                      </a:pPr>
+                      <a:r>
+                        <a:rPr lang="en-US" sz="1050" b="1" dirty="0">
+                          <a:solidFill>
+                            <a:srgbClr val="3D5A3D"/>
+                          </a:solidFill>
+                          <a:latin typeface="Arial" pitchFamily="34" charset="0"/>
+                          <a:ea typeface="Arial" pitchFamily="34" charset="-122"/>
+                          <a:cs typeface="Arial" pitchFamily="34" charset="-120"/>
+                        </a:rPr>
+                        <a:t>1 / 16 (chance)</a:t>
                       </a:r>
                       <a:endParaRPr lang="en-US" sz="1050" dirty="0">
                         <a:latin typeface="Arial" charset="0"/>
@@ -7363,7 +9486,7 @@
                           <a:ea typeface="Arial" pitchFamily="34" charset="-122"/>
                           <a:cs typeface="Arial" pitchFamily="34" charset="-120"/>
                         </a:rPr>
-                        <a:t>0.47 ms</a:t>
+                        <a:t>zero plaintext info</a:t>
                       </a:r>
                       <a:endParaRPr lang="en-US" sz="1050" dirty="0">
                         <a:latin typeface="Arial" charset="0"/>
@@ -7412,7 +9535,214 @@
                   </a:tcPr>
                 </a:tc>
               </a:tr>
-              <a:tr h="411480">
+            </a:tbl>
+          </a:graphicData>
+        </a:graphic>
+      </p:graphicFrame>
+      <p:sp>
+        <p:nvSpPr>
+          <p:cNvPr id="7" name="Text 3"/>
+          <p:cNvSpPr/>
+          <p:nvPr/>
+        </p:nvSpPr>
+        <p:spPr>
+          <a:xfrm>
+            <a:off x="6629400" y="2971800"/>
+            <a:ext cx="5029200" cy="274320"/>
+          </a:xfrm>
+          <a:prstGeom prst="rect">
+            <a:avLst/>
+          </a:prstGeom>
+          <a:noFill/>
+          <a:ln/>
+        </p:spPr>
+        <p:txBody>
+          <a:bodyPr wrap="square" rtlCol="0" anchor="ctr"/>
+          <a:lstStyle/>
+          <a:p>
+            <a:pPr indent="0" marL="0">
+              <a:buNone/>
+            </a:pPr>
+            <a:r>
+              <a:rPr lang="en-US" sz="1200" b="1" dirty="0">
+                <a:solidFill>
+                  <a:srgbClr val="1F4E79"/>
+                </a:solidFill>
+                <a:latin typeface="Arial" pitchFamily="34" charset="0"/>
+                <a:ea typeface="Arial" pitchFamily="34" charset="-122"/>
+                <a:cs typeface="Arial" pitchFamily="34" charset="-120"/>
+              </a:rPr>
+              <a:t>Red team (report section 6.3, executable)</a:t>
+            </a:r>
+            <a:endParaRPr lang="en-US" sz="1200" dirty="0"/>
+          </a:p>
+        </p:txBody>
+      </p:sp>
+      <p:graphicFrame>
+        <p:nvGraphicFramePr>
+          <p:cNvPr id="39" name="Table 1"/>
+          <p:cNvGraphicFramePr>
+            <a:graphicFrameLocks noGrp="1"/>
+          </p:cNvGraphicFramePr>
+          <p:nvPr>
+            <p:extLst>
+              <p:ext uri="{D42A27DB-BD31-4B8C-83A1-F6EECF244321}">
+                <p14:modId xmlns:p14="http://schemas.microsoft.com/office/powerpoint/2010/main" val="1579011935"/>
+              </p:ext>
+            </p:extLst>
+          </p:nvPr>
+        </p:nvGraphicFramePr>
+        <p:xfrm>
+          <a:off x="6629400" y="3291840"/>
+          <a:ext cx="5029200" cy="914400"/>
+        </p:xfrm>
+        <a:graphic>
+          <a:graphicData uri="http://schemas.openxmlformats.org/drawingml/2006/table">
+            <a:tbl>
+              <a:tblPr/>
+              <a:tblGrid>
+                <a:gridCol w="3291840"/>
+                <a:gridCol w="1737360"/>
+              </a:tblGrid>
+              <a:tr h="320040">
+                <a:tc>
+                  <a:txBody>
+                    <a:bodyPr/>
+                    <a:lstStyle/>
+                    <a:p>
+                      <a:pPr indent="0" marL="0">
+                        <a:buNone/>
+                      </a:pPr>
+                      <a:r>
+                        <a:rPr lang="en-US" sz="1100" b="1" dirty="0">
+                          <a:solidFill>
+                            <a:srgbClr val="FFFFFF"/>
+                          </a:solidFill>
+                          <a:latin typeface="Arial" pitchFamily="34" charset="0"/>
+                          <a:ea typeface="Arial" pitchFamily="34" charset="-122"/>
+                          <a:cs typeface="Arial" pitchFamily="34" charset="-120"/>
+                        </a:rPr>
+                        <a:t>Attack</a:t>
+                      </a:r>
+                      <a:endParaRPr lang="en-US" sz="1100" dirty="0">
+                        <a:latin typeface="Arial" charset="0"/>
+                        <a:ea typeface="Arial" charset="0"/>
+                        <a:cs typeface="Arial" charset="0"/>
+                      </a:endParaRPr>
+                    </a:p>
+                  </a:txBody>
+                  <a:tcPr marL="91440" marR="91440" marT="45720" marB="45720" anchor="ctr">
+                    <a:lnL w="6350" cap="flat" cmpd="sng" algn="ctr">
+                      <a:solidFill>
+                        <a:srgbClr val="D6DAE0"/>
+                      </a:solidFill>
+                      <a:prstDash val="solid"/>
+                      <a:round/>
+                      <a:headEnd type="none" w="med" len="med"/>
+                      <a:tailEnd type="none" w="med" len="med"/>
+                    </a:lnL>
+                    <a:lnR w="6350" cap="flat" cmpd="sng" algn="ctr">
+                      <a:solidFill>
+                        <a:srgbClr val="D6DAE0"/>
+                      </a:solidFill>
+                      <a:prstDash val="solid"/>
+                      <a:round/>
+                      <a:headEnd type="none" w="med" len="med"/>
+                      <a:tailEnd type="none" w="med" len="med"/>
+                    </a:lnR>
+                    <a:lnT w="6350" cap="flat" cmpd="sng" algn="ctr">
+                      <a:solidFill>
+                        <a:srgbClr val="D6DAE0"/>
+                      </a:solidFill>
+                      <a:prstDash val="solid"/>
+                      <a:round/>
+                      <a:headEnd type="none" w="med" len="med"/>
+                      <a:tailEnd type="none" w="med" len="med"/>
+                    </a:lnT>
+                    <a:lnB w="6350" cap="flat" cmpd="sng" algn="ctr">
+                      <a:solidFill>
+                        <a:srgbClr val="D6DAE0"/>
+                      </a:solidFill>
+                      <a:prstDash val="solid"/>
+                      <a:round/>
+                      <a:headEnd type="none" w="med" len="med"/>
+                      <a:tailEnd type="none" w="med" len="med"/>
+                    </a:lnB>
+                    <a:solidFill>
+                      <a:srgbClr val="1F4E79"/>
+                    </a:solidFill>
+                  </a:tcPr>
+                </a:tc>
+                <a:tc>
+                  <a:txBody>
+                    <a:bodyPr/>
+                    <a:lstStyle/>
+                    <a:p>
+                      <a:pPr indent="0" marL="0">
+                        <a:buNone/>
+                      </a:pPr>
+                      <a:r>
+                        <a:rPr lang="en-US" sz="1100" b="1" dirty="0">
+                          <a:solidFill>
+                            <a:srgbClr val="FFFFFF"/>
+                          </a:solidFill>
+                          <a:latin typeface="Arial" pitchFamily="34" charset="0"/>
+                          <a:ea typeface="Arial" pitchFamily="34" charset="-122"/>
+                          <a:cs typeface="Arial" pitchFamily="34" charset="-120"/>
+                        </a:rPr>
+                        <a:t>Result</a:t>
+                      </a:r>
+                      <a:endParaRPr lang="en-US" sz="1100" dirty="0">
+                        <a:latin typeface="Arial" charset="0"/>
+                        <a:ea typeface="Arial" charset="0"/>
+                        <a:cs typeface="Arial" charset="0"/>
+                      </a:endParaRPr>
+                    </a:p>
+                  </a:txBody>
+                  <a:tcPr marL="91440" marR="91440" marT="45720" marB="45720" anchor="ctr">
+                    <a:lnL w="6350" cap="flat" cmpd="sng" algn="ctr">
+                      <a:solidFill>
+                        <a:srgbClr val="D6DAE0"/>
+                      </a:solidFill>
+                      <a:prstDash val="solid"/>
+                      <a:round/>
+                      <a:headEnd type="none" w="med" len="med"/>
+                      <a:tailEnd type="none" w="med" len="med"/>
+                    </a:lnL>
+                    <a:lnR w="6350" cap="flat" cmpd="sng" algn="ctr">
+                      <a:solidFill>
+                        <a:srgbClr val="D6DAE0"/>
+                      </a:solidFill>
+                      <a:prstDash val="solid"/>
+                      <a:round/>
+                      <a:headEnd type="none" w="med" len="med"/>
+                      <a:tailEnd type="none" w="med" len="med"/>
+                    </a:lnR>
+                    <a:lnT w="6350" cap="flat" cmpd="sng" algn="ctr">
+                      <a:solidFill>
+                        <a:srgbClr val="D6DAE0"/>
+                      </a:solidFill>
+                      <a:prstDash val="solid"/>
+                      <a:round/>
+                      <a:headEnd type="none" w="med" len="med"/>
+                      <a:tailEnd type="none" w="med" len="med"/>
+                    </a:lnT>
+                    <a:lnB w="6350" cap="flat" cmpd="sng" algn="ctr">
+                      <a:solidFill>
+                        <a:srgbClr val="D6DAE0"/>
+                      </a:solidFill>
+                      <a:prstDash val="solid"/>
+                      <a:round/>
+                      <a:headEnd type="none" w="med" len="med"/>
+                      <a:tailEnd type="none" w="med" len="med"/>
+                    </a:lnB>
+                    <a:solidFill>
+                      <a:srgbClr val="1F4E79"/>
+                    </a:solidFill>
+                  </a:tcPr>
+                </a:tc>
+              </a:tr>
+              <a:tr h="320040">
                 <a:tc>
                   <a:txBody>
                     <a:bodyPr/>
@@ -7430,7 +9760,7 @@
                           <a:ea typeface="Arial" pitchFamily="34" charset="-122"/>
                           <a:cs typeface="Arial" pitchFamily="34" charset="-120"/>
                         </a:rPr>
-                        <a:t>Egress gate: validate + tripwire + vault + guard</a:t>
+                        <a:t>PII split across adjacent DOM nodes</a:t>
                       </a:r>
                       <a:endParaRPr lang="en-US" sz="1050" dirty="0">
                         <a:latin typeface="Arial" charset="0"/>
@@ -7478,6 +9808,73 @@
                     </a:lnB>
                   </a:tcPr>
                 </a:tc>
+                <a:tc>
+                  <a:txBody>
+                    <a:bodyPr/>
+                    <a:lstStyle/>
+                    <a:p>
+                      <a:pPr indent="0" marL="0">
+                        <a:buNone/>
+                      </a:pPr>
+                      <a:r>
+                        <a:rPr lang="en-US" sz="1050" b="1" dirty="0">
+                          <a:solidFill>
+                            <a:srgbClr val="3D5A3D"/>
+                          </a:solidFill>
+                          <a:latin typeface="Arial" pitchFamily="34" charset="0"/>
+                          <a:ea typeface="Arial" pitchFamily="34" charset="-122"/>
+                          <a:cs typeface="Arial" pitchFamily="34" charset="-120"/>
+                        </a:rPr>
+                        <a:t>caught, reassembled</a:t>
+                      </a:r>
+                      <a:endParaRPr lang="en-US" sz="1050" dirty="0">
+                        <a:latin typeface="Arial" charset="0"/>
+                        <a:ea typeface="Arial" charset="0"/>
+                        <a:cs typeface="Arial" charset="0"/>
+                      </a:endParaRPr>
+                    </a:p>
+                  </a:txBody>
+                  <a:tcPr marL="91440" marR="91440" marT="45720" marB="45720" anchor="ctr">
+                    <a:lnL w="6350" cap="flat" cmpd="sng" algn="ctr">
+                      <a:solidFill>
+                        <a:srgbClr val="D6DAE0"/>
+                      </a:solidFill>
+                      <a:prstDash val="solid"/>
+                      <a:round/>
+                      <a:headEnd type="none" w="med" len="med"/>
+                      <a:tailEnd type="none" w="med" len="med"/>
+                    </a:lnL>
+                    <a:lnR w="6350" cap="flat" cmpd="sng" algn="ctr">
+                      <a:solidFill>
+                        <a:srgbClr val="D6DAE0"/>
+                      </a:solidFill>
+                      <a:prstDash val="solid"/>
+                      <a:round/>
+                      <a:headEnd type="none" w="med" len="med"/>
+                      <a:tailEnd type="none" w="med" len="med"/>
+                    </a:lnR>
+                    <a:lnT w="6350" cap="flat" cmpd="sng" algn="ctr">
+                      <a:solidFill>
+                        <a:srgbClr val="D6DAE0"/>
+                      </a:solidFill>
+                      <a:prstDash val="solid"/>
+                      <a:round/>
+                      <a:headEnd type="none" w="med" len="med"/>
+                      <a:tailEnd type="none" w="med" len="med"/>
+                    </a:lnT>
+                    <a:lnB w="6350" cap="flat" cmpd="sng" algn="ctr">
+                      <a:solidFill>
+                        <a:srgbClr val="D6DAE0"/>
+                      </a:solidFill>
+                      <a:prstDash val="solid"/>
+                      <a:round/>
+                      <a:headEnd type="none" w="med" len="med"/>
+                      <a:tailEnd type="none" w="med" len="med"/>
+                    </a:lnB>
+                  </a:tcPr>
+                </a:tc>
+              </a:tr>
+              <a:tr h="320040">
                 <a:tc>
                   <a:txBody>
                     <a:bodyPr/>
@@ -7495,7 +9892,7 @@
                           <a:ea typeface="Arial" pitchFamily="34" charset="-122"/>
                           <a:cs typeface="Arial" pitchFamily="34" charset="-120"/>
                         </a:rPr>
-                        <a:t>0.14 ms</a:t>
+                        <a:t>Prompt injection in page content</a:t>
                       </a:r>
                       <a:endParaRPr lang="en-US" sz="1050" dirty="0">
                         <a:latin typeface="Arial" charset="0"/>
@@ -7543,6 +9940,73 @@
                     </a:lnB>
                   </a:tcPr>
                 </a:tc>
+                <a:tc>
+                  <a:txBody>
+                    <a:bodyPr/>
+                    <a:lstStyle/>
+                    <a:p>
+                      <a:pPr indent="0" marL="0">
+                        <a:buNone/>
+                      </a:pPr>
+                      <a:r>
+                        <a:rPr lang="en-US" sz="1050" b="1" dirty="0">
+                          <a:solidFill>
+                            <a:srgbClr val="3D5A3D"/>
+                          </a:solidFill>
+                          <a:latin typeface="Arial" pitchFamily="34" charset="0"/>
+                          <a:ea typeface="Arial" pitchFamily="34" charset="-122"/>
+                          <a:cs typeface="Arial" pitchFamily="34" charset="-120"/>
+                        </a:rPr>
+                        <a:t>quarantined</a:t>
+                      </a:r>
+                      <a:endParaRPr lang="en-US" sz="1050" dirty="0">
+                        <a:latin typeface="Arial" charset="0"/>
+                        <a:ea typeface="Arial" charset="0"/>
+                        <a:cs typeface="Arial" charset="0"/>
+                      </a:endParaRPr>
+                    </a:p>
+                  </a:txBody>
+                  <a:tcPr marL="91440" marR="91440" marT="45720" marB="45720" anchor="ctr">
+                    <a:lnL w="6350" cap="flat" cmpd="sng" algn="ctr">
+                      <a:solidFill>
+                        <a:srgbClr val="D6DAE0"/>
+                      </a:solidFill>
+                      <a:prstDash val="solid"/>
+                      <a:round/>
+                      <a:headEnd type="none" w="med" len="med"/>
+                      <a:tailEnd type="none" w="med" len="med"/>
+                    </a:lnL>
+                    <a:lnR w="6350" cap="flat" cmpd="sng" algn="ctr">
+                      <a:solidFill>
+                        <a:srgbClr val="D6DAE0"/>
+                      </a:solidFill>
+                      <a:prstDash val="solid"/>
+                      <a:round/>
+                      <a:headEnd type="none" w="med" len="med"/>
+                      <a:tailEnd type="none" w="med" len="med"/>
+                    </a:lnR>
+                    <a:lnT w="6350" cap="flat" cmpd="sng" algn="ctr">
+                      <a:solidFill>
+                        <a:srgbClr val="D6DAE0"/>
+                      </a:solidFill>
+                      <a:prstDash val="solid"/>
+                      <a:round/>
+                      <a:headEnd type="none" w="med" len="med"/>
+                      <a:tailEnd type="none" w="med" len="med"/>
+                    </a:lnT>
+                    <a:lnB w="6350" cap="flat" cmpd="sng" algn="ctr">
+                      <a:solidFill>
+                        <a:srgbClr val="D6DAE0"/>
+                      </a:solidFill>
+                      <a:prstDash val="solid"/>
+                      <a:round/>
+                      <a:headEnd type="none" w="med" len="med"/>
+                      <a:tailEnd type="none" w="med" len="med"/>
+                    </a:lnB>
+                  </a:tcPr>
+                </a:tc>
+              </a:tr>
+              <a:tr h="320040">
                 <a:tc>
                   <a:txBody>
                     <a:bodyPr/>
@@ -7560,7 +10024,7 @@
                           <a:ea typeface="Arial" pitchFamily="34" charset="-122"/>
                           <a:cs typeface="Arial" pitchFamily="34" charset="-120"/>
                         </a:rPr>
-                        <a:t>0.29 ms</a:t>
+                        <a:t>Compromised server names foreign element</a:t>
                       </a:r>
                       <a:endParaRPr lang="en-US" sz="1050" dirty="0">
                         <a:latin typeface="Arial" charset="0"/>
@@ -7608,8 +10072,73 @@
                     </a:lnB>
                   </a:tcPr>
                 </a:tc>
+                <a:tc>
+                  <a:txBody>
+                    <a:bodyPr/>
+                    <a:lstStyle/>
+                    <a:p>
+                      <a:pPr indent="0" marL="0">
+                        <a:buNone/>
+                      </a:pPr>
+                      <a:r>
+                        <a:rPr lang="en-US" sz="1050" b="1" dirty="0">
+                          <a:solidFill>
+                            <a:srgbClr val="3D5A3D"/>
+                          </a:solidFill>
+                          <a:latin typeface="Arial" pitchFamily="34" charset="0"/>
+                          <a:ea typeface="Arial" pitchFamily="34" charset="-122"/>
+                          <a:cs typeface="Arial" pitchFamily="34" charset="-120"/>
+                        </a:rPr>
+                        <a:t>plan rejected</a:t>
+                      </a:r>
+                      <a:endParaRPr lang="en-US" sz="1050" dirty="0">
+                        <a:latin typeface="Arial" charset="0"/>
+                        <a:ea typeface="Arial" charset="0"/>
+                        <a:cs typeface="Arial" charset="0"/>
+                      </a:endParaRPr>
+                    </a:p>
+                  </a:txBody>
+                  <a:tcPr marL="91440" marR="91440" marT="45720" marB="45720" anchor="ctr">
+                    <a:lnL w="6350" cap="flat" cmpd="sng" algn="ctr">
+                      <a:solidFill>
+                        <a:srgbClr val="D6DAE0"/>
+                      </a:solidFill>
+                      <a:prstDash val="solid"/>
+                      <a:round/>
+                      <a:headEnd type="none" w="med" len="med"/>
+                      <a:tailEnd type="none" w="med" len="med"/>
+                    </a:lnL>
+                    <a:lnR w="6350" cap="flat" cmpd="sng" algn="ctr">
+                      <a:solidFill>
+                        <a:srgbClr val="D6DAE0"/>
+                      </a:solidFill>
+                      <a:prstDash val="solid"/>
+                      <a:round/>
+                      <a:headEnd type="none" w="med" len="med"/>
+                      <a:tailEnd type="none" w="med" len="med"/>
+                    </a:lnR>
+                    <a:lnT w="6350" cap="flat" cmpd="sng" algn="ctr">
+                      <a:solidFill>
+                        <a:srgbClr val="D6DAE0"/>
+                      </a:solidFill>
+                      <a:prstDash val="solid"/>
+                      <a:round/>
+                      <a:headEnd type="none" w="med" len="med"/>
+                      <a:tailEnd type="none" w="med" len="med"/>
+                    </a:lnT>
+                    <a:lnB w="6350" cap="flat" cmpd="sng" algn="ctr">
+                      <a:solidFill>
+                        <a:srgbClr val="D6DAE0"/>
+                      </a:solidFill>
+                      <a:prstDash val="solid"/>
+                      <a:round/>
+                      <a:headEnd type="none" w="med" len="med"/>
+                      <a:tailEnd type="none" w="med" len="med"/>
+                    </a:lnB>
+                  </a:tcPr>
+                </a:tc>
               </a:tr>
-              <a:tr h="411480">
+              <a:tr h="320040">
                 <a:tc>
                   <a:txBody>
                     <a:bodyPr/>
@@ -7627,7 +10156,7 @@
                           <a:ea typeface="Arial" pitchFamily="34" charset="-122"/>
                           <a:cs typeface="Arial" pitchFamily="34" charset="-120"/>
                         </a:rPr>
-                        <a:t>Tile hashing (dirty-region skip), 1024x580</a:t>
+                        <a:t>PII smuggled via notes / history fields</a:t>
                       </a:r>
                       <a:endParaRPr lang="en-US" sz="1050" dirty="0">
                         <a:latin typeface="Arial" charset="0"/>
@@ -7675,6 +10204,73 @@
                     </a:lnB>
                   </a:tcPr>
                 </a:tc>
+                <a:tc>
+                  <a:txBody>
+                    <a:bodyPr/>
+                    <a:lstStyle/>
+                    <a:p>
+                      <a:pPr indent="0" marL="0">
+                        <a:buNone/>
+                      </a:pPr>
+                      <a:r>
+                        <a:rPr lang="en-US" sz="1050" b="1" dirty="0">
+                          <a:solidFill>
+                            <a:srgbClr val="3D5A3D"/>
+                          </a:solidFill>
+                          <a:latin typeface="Arial" pitchFamily="34" charset="0"/>
+                          <a:ea typeface="Arial" pitchFamily="34" charset="-122"/>
+                          <a:cs typeface="Arial" pitchFamily="34" charset="-120"/>
+                        </a:rPr>
+                        <a:t>gate blocks</a:t>
+                      </a:r>
+                      <a:endParaRPr lang="en-US" sz="1050" dirty="0">
+                        <a:latin typeface="Arial" charset="0"/>
+                        <a:ea typeface="Arial" charset="0"/>
+                        <a:cs typeface="Arial" charset="0"/>
+                      </a:endParaRPr>
+                    </a:p>
+                  </a:txBody>
+                  <a:tcPr marL="91440" marR="91440" marT="45720" marB="45720" anchor="ctr">
+                    <a:lnL w="6350" cap="flat" cmpd="sng" algn="ctr">
+                      <a:solidFill>
+                        <a:srgbClr val="D6DAE0"/>
+                      </a:solidFill>
+                      <a:prstDash val="solid"/>
+                      <a:round/>
+                      <a:headEnd type="none" w="med" len="med"/>
+                      <a:tailEnd type="none" w="med" len="med"/>
+                    </a:lnL>
+                    <a:lnR w="6350" cap="flat" cmpd="sng" algn="ctr">
+                      <a:solidFill>
+                        <a:srgbClr val="D6DAE0"/>
+                      </a:solidFill>
+                      <a:prstDash val="solid"/>
+                      <a:round/>
+                      <a:headEnd type="none" w="med" len="med"/>
+                      <a:tailEnd type="none" w="med" len="med"/>
+                    </a:lnR>
+                    <a:lnT w="6350" cap="flat" cmpd="sng" algn="ctr">
+                      <a:solidFill>
+                        <a:srgbClr val="D6DAE0"/>
+                      </a:solidFill>
+                      <a:prstDash val="solid"/>
+                      <a:round/>
+                      <a:headEnd type="none" w="med" len="med"/>
+                      <a:tailEnd type="none" w="med" len="med"/>
+                    </a:lnT>
+                    <a:lnB w="6350" cap="flat" cmpd="sng" algn="ctr">
+                      <a:solidFill>
+                        <a:srgbClr val="D6DAE0"/>
+                      </a:solidFill>
+                      <a:prstDash val="solid"/>
+                      <a:round/>
+                      <a:headEnd type="none" w="med" len="med"/>
+                      <a:tailEnd type="none" w="med" len="med"/>
+                    </a:lnB>
+                  </a:tcPr>
+                </a:tc>
+              </a:tr>
+              <a:tr h="320040">
                 <a:tc>
                   <a:txBody>
                     <a:bodyPr/>
@@ -7692,7 +10288,7 @@
                           <a:ea typeface="Arial" pitchFamily="34" charset="-122"/>
                           <a:cs typeface="Arial" pitchFamily="34" charset="-120"/>
                         </a:rPr>
-                        <a:t>0.21 ms</a:t>
+                        <a:t>Leaky packet sent straight to server</a:t>
                       </a:r>
                       <a:endParaRPr lang="en-US" sz="1050" dirty="0">
                         <a:latin typeface="Arial" charset="0"/>
@@ -7740,6 +10336,73 @@
                     </a:lnB>
                   </a:tcPr>
                 </a:tc>
+                <a:tc>
+                  <a:txBody>
+                    <a:bodyPr/>
+                    <a:lstStyle/>
+                    <a:p>
+                      <a:pPr indent="0" marL="0">
+                        <a:buNone/>
+                      </a:pPr>
+                      <a:r>
+                        <a:rPr lang="en-US" sz="1050" b="1" dirty="0">
+                          <a:solidFill>
+                            <a:srgbClr val="3D5A3D"/>
+                          </a:solidFill>
+                          <a:latin typeface="Arial" pitchFamily="34" charset="0"/>
+                          <a:ea typeface="Arial" pitchFamily="34" charset="-122"/>
+                          <a:cs typeface="Arial" pitchFamily="34" charset="-120"/>
+                        </a:rPr>
+                        <a:t>422, never processed</a:t>
+                      </a:r>
+                      <a:endParaRPr lang="en-US" sz="1050" dirty="0">
+                        <a:latin typeface="Arial" charset="0"/>
+                        <a:ea typeface="Arial" charset="0"/>
+                        <a:cs typeface="Arial" charset="0"/>
+                      </a:endParaRPr>
+                    </a:p>
+                  </a:txBody>
+                  <a:tcPr marL="91440" marR="91440" marT="45720" marB="45720" anchor="ctr">
+                    <a:lnL w="6350" cap="flat" cmpd="sng" algn="ctr">
+                      <a:solidFill>
+                        <a:srgbClr val="D6DAE0"/>
+                      </a:solidFill>
+                      <a:prstDash val="solid"/>
+                      <a:round/>
+                      <a:headEnd type="none" w="med" len="med"/>
+                      <a:tailEnd type="none" w="med" len="med"/>
+                    </a:lnL>
+                    <a:lnR w="6350" cap="flat" cmpd="sng" algn="ctr">
+                      <a:solidFill>
+                        <a:srgbClr val="D6DAE0"/>
+                      </a:solidFill>
+                      <a:prstDash val="solid"/>
+                      <a:round/>
+                      <a:headEnd type="none" w="med" len="med"/>
+                      <a:tailEnd type="none" w="med" len="med"/>
+                    </a:lnR>
+                    <a:lnT w="6350" cap="flat" cmpd="sng" algn="ctr">
+                      <a:solidFill>
+                        <a:srgbClr val="D6DAE0"/>
+                      </a:solidFill>
+                      <a:prstDash val="solid"/>
+                      <a:round/>
+                      <a:headEnd type="none" w="med" len="med"/>
+                      <a:tailEnd type="none" w="med" len="med"/>
+                    </a:lnT>
+                    <a:lnB w="6350" cap="flat" cmpd="sng" algn="ctr">
+                      <a:solidFill>
+                        <a:srgbClr val="D6DAE0"/>
+                      </a:solidFill>
+                      <a:prstDash val="solid"/>
+                      <a:round/>
+                      <a:headEnd type="none" w="med" len="med"/>
+                      <a:tailEnd type="none" w="med" len="med"/>
+                    </a:lnB>
+                  </a:tcPr>
+                </a:tc>
+              </a:tr>
+              <a:tr h="320040">
                 <a:tc>
                   <a:txBody>
                     <a:bodyPr/>
@@ -7757,7 +10420,7 @@
                           <a:ea typeface="Arial" pitchFamily="34" charset="-122"/>
                           <a:cs typeface="Arial" pitchFamily="34" charset="-120"/>
                         </a:rPr>
-                        <a:t>0.75 ms</a:t>
+                        <a:t>700-element packet / 1000-region page</a:t>
                       </a:r>
                       <a:endParaRPr lang="en-US" sz="1050" dirty="0">
                         <a:latin typeface="Arial" charset="0"/>
@@ -7805,8 +10468,73 @@
                     </a:lnB>
                   </a:tcPr>
                 </a:tc>
+                <a:tc>
+                  <a:txBody>
+                    <a:bodyPr/>
+                    <a:lstStyle/>
+                    <a:p>
+                      <a:pPr indent="0" marL="0">
+                        <a:buNone/>
+                      </a:pPr>
+                      <a:r>
+                        <a:rPr lang="en-US" sz="1050" b="1" dirty="0">
+                          <a:solidFill>
+                            <a:srgbClr val="3D5A3D"/>
+                          </a:solidFill>
+                          <a:latin typeface="Arial" pitchFamily="34" charset="0"/>
+                          <a:ea typeface="Arial" pitchFamily="34" charset="-122"/>
+                          <a:cs typeface="Arial" pitchFamily="34" charset="-120"/>
+                        </a:rPr>
+                        <a:t>capped, bounded</a:t>
+                      </a:r>
+                      <a:endParaRPr lang="en-US" sz="1050" dirty="0">
+                        <a:latin typeface="Arial" charset="0"/>
+                        <a:ea typeface="Arial" charset="0"/>
+                        <a:cs typeface="Arial" charset="0"/>
+                      </a:endParaRPr>
+                    </a:p>
+                  </a:txBody>
+                  <a:tcPr marL="91440" marR="91440" marT="45720" marB="45720" anchor="ctr">
+                    <a:lnL w="6350" cap="flat" cmpd="sng" algn="ctr">
+                      <a:solidFill>
+                        <a:srgbClr val="D6DAE0"/>
+                      </a:solidFill>
+                      <a:prstDash val="solid"/>
+                      <a:round/>
+                      <a:headEnd type="none" w="med" len="med"/>
+                      <a:tailEnd type="none" w="med" len="med"/>
+                    </a:lnL>
+                    <a:lnR w="6350" cap="flat" cmpd="sng" algn="ctr">
+                      <a:solidFill>
+                        <a:srgbClr val="D6DAE0"/>
+                      </a:solidFill>
+                      <a:prstDash val="solid"/>
+                      <a:round/>
+                      <a:headEnd type="none" w="med" len="med"/>
+                      <a:tailEnd type="none" w="med" len="med"/>
+                    </a:lnR>
+                    <a:lnT w="6350" cap="flat" cmpd="sng" algn="ctr">
+                      <a:solidFill>
+                        <a:srgbClr val="D6DAE0"/>
+                      </a:solidFill>
+                      <a:prstDash val="solid"/>
+                      <a:round/>
+                      <a:headEnd type="none" w="med" len="med"/>
+                      <a:tailEnd type="none" w="med" len="med"/>
+                    </a:lnT>
+                    <a:lnB w="6350" cap="flat" cmpd="sng" algn="ctr">
+                      <a:solidFill>
+                        <a:srgbClr val="D6DAE0"/>
+                      </a:solidFill>
+                      <a:prstDash val="solid"/>
+                      <a:round/>
+                      <a:headEnd type="none" w="med" len="med"/>
+                      <a:tailEnd type="none" w="med" len="med"/>
+                    </a:lnB>
+                  </a:tcPr>
+                </a:tc>
               </a:tr>
-              <a:tr h="411480">
+              <a:tr h="320040">
                 <a:tc>
                   <a:txBody>
                     <a:bodyPr/>
@@ -7824,401 +10552,7 @@
                           <a:ea typeface="Arial" pitchFamily="34" charset="-122"/>
                           <a:cs typeface="Arial" pitchFamily="34" charset="-120"/>
                         </a:rPr>
-                        <a:t>Compose + pixel self-check (8 redactions)</a:t>
-                      </a:r>
-                      <a:endParaRPr lang="en-US" sz="1050" dirty="0">
-                        <a:latin typeface="Arial" charset="0"/>
-                        <a:ea typeface="Arial" charset="0"/>
-                        <a:cs typeface="Arial" charset="0"/>
-                      </a:endParaRPr>
-                    </a:p>
-                  </a:txBody>
-                  <a:tcPr marL="91440" marR="91440" marT="45720" marB="45720" anchor="ctr">
-                    <a:lnL w="6350" cap="flat" cmpd="sng" algn="ctr">
-                      <a:solidFill>
-                        <a:srgbClr val="D6DAE0"/>
-                      </a:solidFill>
-                      <a:prstDash val="solid"/>
-                      <a:round/>
-                      <a:headEnd type="none" w="med" len="med"/>
-                      <a:tailEnd type="none" w="med" len="med"/>
-                    </a:lnL>
-                    <a:lnR w="6350" cap="flat" cmpd="sng" algn="ctr">
-                      <a:solidFill>
-                        <a:srgbClr val="D6DAE0"/>
-                      </a:solidFill>
-                      <a:prstDash val="solid"/>
-                      <a:round/>
-                      <a:headEnd type="none" w="med" len="med"/>
-                      <a:tailEnd type="none" w="med" len="med"/>
-                    </a:lnR>
-                    <a:lnT w="6350" cap="flat" cmpd="sng" algn="ctr">
-                      <a:solidFill>
-                        <a:srgbClr val="D6DAE0"/>
-                      </a:solidFill>
-                      <a:prstDash val="solid"/>
-                      <a:round/>
-                      <a:headEnd type="none" w="med" len="med"/>
-                      <a:tailEnd type="none" w="med" len="med"/>
-                    </a:lnT>
-                    <a:lnB w="6350" cap="flat" cmpd="sng" algn="ctr">
-                      <a:solidFill>
-                        <a:srgbClr val="D6DAE0"/>
-                      </a:solidFill>
-                      <a:prstDash val="solid"/>
-                      <a:round/>
-                      <a:headEnd type="none" w="med" len="med"/>
-                      <a:tailEnd type="none" w="med" len="med"/>
-                    </a:lnB>
-                  </a:tcPr>
-                </a:tc>
-                <a:tc>
-                  <a:txBody>
-                    <a:bodyPr/>
-                    <a:lstStyle/>
-                    <a:p>
-                      <a:pPr indent="0" marL="0">
-                        <a:buNone/>
-                      </a:pPr>
-                      <a:r>
-                        <a:rPr lang="en-US" sz="1050" dirty="0">
-                          <a:solidFill>
-                            <a:srgbClr val="16181D"/>
-                          </a:solidFill>
-                          <a:latin typeface="Arial" pitchFamily="34" charset="0"/>
-                          <a:ea typeface="Arial" pitchFamily="34" charset="-122"/>
-                          <a:cs typeface="Arial" pitchFamily="34" charset="-120"/>
-                        </a:rPr>
-                        <a:t>1.88 ms</a:t>
-                      </a:r>
-                      <a:endParaRPr lang="en-US" sz="1050" dirty="0">
-                        <a:latin typeface="Arial" charset="0"/>
-                        <a:ea typeface="Arial" charset="0"/>
-                        <a:cs typeface="Arial" charset="0"/>
-                      </a:endParaRPr>
-                    </a:p>
-                  </a:txBody>
-                  <a:tcPr marL="91440" marR="91440" marT="45720" marB="45720" anchor="ctr">
-                    <a:lnL w="6350" cap="flat" cmpd="sng" algn="ctr">
-                      <a:solidFill>
-                        <a:srgbClr val="D6DAE0"/>
-                      </a:solidFill>
-                      <a:prstDash val="solid"/>
-                      <a:round/>
-                      <a:headEnd type="none" w="med" len="med"/>
-                      <a:tailEnd type="none" w="med" len="med"/>
-                    </a:lnL>
-                    <a:lnR w="6350" cap="flat" cmpd="sng" algn="ctr">
-                      <a:solidFill>
-                        <a:srgbClr val="D6DAE0"/>
-                      </a:solidFill>
-                      <a:prstDash val="solid"/>
-                      <a:round/>
-                      <a:headEnd type="none" w="med" len="med"/>
-                      <a:tailEnd type="none" w="med" len="med"/>
-                    </a:lnR>
-                    <a:lnT w="6350" cap="flat" cmpd="sng" algn="ctr">
-                      <a:solidFill>
-                        <a:srgbClr val="D6DAE0"/>
-                      </a:solidFill>
-                      <a:prstDash val="solid"/>
-                      <a:round/>
-                      <a:headEnd type="none" w="med" len="med"/>
-                      <a:tailEnd type="none" w="med" len="med"/>
-                    </a:lnT>
-                    <a:lnB w="6350" cap="flat" cmpd="sng" algn="ctr">
-                      <a:solidFill>
-                        <a:srgbClr val="D6DAE0"/>
-                      </a:solidFill>
-                      <a:prstDash val="solid"/>
-                      <a:round/>
-                      <a:headEnd type="none" w="med" len="med"/>
-                      <a:tailEnd type="none" w="med" len="med"/>
-                    </a:lnB>
-                  </a:tcPr>
-                </a:tc>
-                <a:tc>
-                  <a:txBody>
-                    <a:bodyPr/>
-                    <a:lstStyle/>
-                    <a:p>
-                      <a:pPr indent="0" marL="0">
-                        <a:buNone/>
-                      </a:pPr>
-                      <a:r>
-                        <a:rPr lang="en-US" sz="1050" dirty="0">
-                          <a:solidFill>
-                            <a:srgbClr val="16181D"/>
-                          </a:solidFill>
-                          <a:latin typeface="Arial" pitchFamily="34" charset="0"/>
-                          <a:ea typeface="Arial" pitchFamily="34" charset="-122"/>
-                          <a:cs typeface="Arial" pitchFamily="34" charset="-120"/>
-                        </a:rPr>
-                        <a:t>3.57 ms</a:t>
-                      </a:r>
-                      <a:endParaRPr lang="en-US" sz="1050" dirty="0">
-                        <a:latin typeface="Arial" charset="0"/>
-                        <a:ea typeface="Arial" charset="0"/>
-                        <a:cs typeface="Arial" charset="0"/>
-                      </a:endParaRPr>
-                    </a:p>
-                  </a:txBody>
-                  <a:tcPr marL="91440" marR="91440" marT="45720" marB="45720" anchor="ctr">
-                    <a:lnL w="6350" cap="flat" cmpd="sng" algn="ctr">
-                      <a:solidFill>
-                        <a:srgbClr val="D6DAE0"/>
-                      </a:solidFill>
-                      <a:prstDash val="solid"/>
-                      <a:round/>
-                      <a:headEnd type="none" w="med" len="med"/>
-                      <a:tailEnd type="none" w="med" len="med"/>
-                    </a:lnL>
-                    <a:lnR w="6350" cap="flat" cmpd="sng" algn="ctr">
-                      <a:solidFill>
-                        <a:srgbClr val="D6DAE0"/>
-                      </a:solidFill>
-                      <a:prstDash val="solid"/>
-                      <a:round/>
-                      <a:headEnd type="none" w="med" len="med"/>
-                      <a:tailEnd type="none" w="med" len="med"/>
-                    </a:lnR>
-                    <a:lnT w="6350" cap="flat" cmpd="sng" algn="ctr">
-                      <a:solidFill>
-                        <a:srgbClr val="D6DAE0"/>
-                      </a:solidFill>
-                      <a:prstDash val="solid"/>
-                      <a:round/>
-                      <a:headEnd type="none" w="med" len="med"/>
-                      <a:tailEnd type="none" w="med" len="med"/>
-                    </a:lnT>
-                    <a:lnB w="6350" cap="flat" cmpd="sng" algn="ctr">
-                      <a:solidFill>
-                        <a:srgbClr val="D6DAE0"/>
-                      </a:solidFill>
-                      <a:prstDash val="solid"/>
-                      <a:round/>
-                      <a:headEnd type="none" w="med" len="med"/>
-                      <a:tailEnd type="none" w="med" len="med"/>
-                    </a:lnB>
-                  </a:tcPr>
-                </a:tc>
-              </a:tr>
-              <a:tr h="411480">
-                <a:tc>
-                  <a:txBody>
-                    <a:bodyPr/>
-                    <a:lstStyle/>
-                    <a:p>
-                      <a:pPr indent="0" marL="0">
-                        <a:buNone/>
-                      </a:pPr>
-                      <a:r>
-                        <a:rPr lang="en-US" sz="1050" dirty="0">
-                          <a:solidFill>
-                            <a:srgbClr val="16181D"/>
-                          </a:solidFill>
-                          <a:latin typeface="Arial" pitchFamily="34" charset="0"/>
-                          <a:ea typeface="Arial" pitchFamily="34" charset="-122"/>
-                          <a:cs typeface="Arial" pitchFamily="34" charset="-120"/>
-                        </a:rPr>
-                        <a:t>Face preprocess (resize + normalize)</a:t>
-                      </a:r>
-                      <a:endParaRPr lang="en-US" sz="1050" dirty="0">
-                        <a:latin typeface="Arial" charset="0"/>
-                        <a:ea typeface="Arial" charset="0"/>
-                        <a:cs typeface="Arial" charset="0"/>
-                      </a:endParaRPr>
-                    </a:p>
-                  </a:txBody>
-                  <a:tcPr marL="91440" marR="91440" marT="45720" marB="45720" anchor="ctr">
-                    <a:lnL w="6350" cap="flat" cmpd="sng" algn="ctr">
-                      <a:solidFill>
-                        <a:srgbClr val="D6DAE0"/>
-                      </a:solidFill>
-                      <a:prstDash val="solid"/>
-                      <a:round/>
-                      <a:headEnd type="none" w="med" len="med"/>
-                      <a:tailEnd type="none" w="med" len="med"/>
-                    </a:lnL>
-                    <a:lnR w="6350" cap="flat" cmpd="sng" algn="ctr">
-                      <a:solidFill>
-                        <a:srgbClr val="D6DAE0"/>
-                      </a:solidFill>
-                      <a:prstDash val="solid"/>
-                      <a:round/>
-                      <a:headEnd type="none" w="med" len="med"/>
-                      <a:tailEnd type="none" w="med" len="med"/>
-                    </a:lnR>
-                    <a:lnT w="6350" cap="flat" cmpd="sng" algn="ctr">
-                      <a:solidFill>
-                        <a:srgbClr val="D6DAE0"/>
-                      </a:solidFill>
-                      <a:prstDash val="solid"/>
-                      <a:round/>
-                      <a:headEnd type="none" w="med" len="med"/>
-                      <a:tailEnd type="none" w="med" len="med"/>
-                    </a:lnT>
-                    <a:lnB w="6350" cap="flat" cmpd="sng" algn="ctr">
-                      <a:solidFill>
-                        <a:srgbClr val="D6DAE0"/>
-                      </a:solidFill>
-                      <a:prstDash val="solid"/>
-                      <a:round/>
-                      <a:headEnd type="none" w="med" len="med"/>
-                      <a:tailEnd type="none" w="med" len="med"/>
-                    </a:lnB>
-                  </a:tcPr>
-                </a:tc>
-                <a:tc>
-                  <a:txBody>
-                    <a:bodyPr/>
-                    <a:lstStyle/>
-                    <a:p>
-                      <a:pPr indent="0" marL="0">
-                        <a:buNone/>
-                      </a:pPr>
-                      <a:r>
-                        <a:rPr lang="en-US" sz="1050" dirty="0">
-                          <a:solidFill>
-                            <a:srgbClr val="16181D"/>
-                          </a:solidFill>
-                          <a:latin typeface="Arial" pitchFamily="34" charset="0"/>
-                          <a:ea typeface="Arial" pitchFamily="34" charset="-122"/>
-                          <a:cs typeface="Arial" pitchFamily="34" charset="-120"/>
-                        </a:rPr>
-                        <a:t>1.01 ms</a:t>
-                      </a:r>
-                      <a:endParaRPr lang="en-US" sz="1050" dirty="0">
-                        <a:latin typeface="Arial" charset="0"/>
-                        <a:ea typeface="Arial" charset="0"/>
-                        <a:cs typeface="Arial" charset="0"/>
-                      </a:endParaRPr>
-                    </a:p>
-                  </a:txBody>
-                  <a:tcPr marL="91440" marR="91440" marT="45720" marB="45720" anchor="ctr">
-                    <a:lnL w="6350" cap="flat" cmpd="sng" algn="ctr">
-                      <a:solidFill>
-                        <a:srgbClr val="D6DAE0"/>
-                      </a:solidFill>
-                      <a:prstDash val="solid"/>
-                      <a:round/>
-                      <a:headEnd type="none" w="med" len="med"/>
-                      <a:tailEnd type="none" w="med" len="med"/>
-                    </a:lnL>
-                    <a:lnR w="6350" cap="flat" cmpd="sng" algn="ctr">
-                      <a:solidFill>
-                        <a:srgbClr val="D6DAE0"/>
-                      </a:solidFill>
-                      <a:prstDash val="solid"/>
-                      <a:round/>
-                      <a:headEnd type="none" w="med" len="med"/>
-                      <a:tailEnd type="none" w="med" len="med"/>
-                    </a:lnR>
-                    <a:lnT w="6350" cap="flat" cmpd="sng" algn="ctr">
-                      <a:solidFill>
-                        <a:srgbClr val="D6DAE0"/>
-                      </a:solidFill>
-                      <a:prstDash val="solid"/>
-                      <a:round/>
-                      <a:headEnd type="none" w="med" len="med"/>
-                      <a:tailEnd type="none" w="med" len="med"/>
-                    </a:lnT>
-                    <a:lnB w="6350" cap="flat" cmpd="sng" algn="ctr">
-                      <a:solidFill>
-                        <a:srgbClr val="D6DAE0"/>
-                      </a:solidFill>
-                      <a:prstDash val="solid"/>
-                      <a:round/>
-                      <a:headEnd type="none" w="med" len="med"/>
-                      <a:tailEnd type="none" w="med" len="med"/>
-                    </a:lnB>
-                  </a:tcPr>
-                </a:tc>
-                <a:tc>
-                  <a:txBody>
-                    <a:bodyPr/>
-                    <a:lstStyle/>
-                    <a:p>
-                      <a:pPr indent="0" marL="0">
-                        <a:buNone/>
-                      </a:pPr>
-                      <a:r>
-                        <a:rPr lang="en-US" sz="1050" dirty="0">
-                          <a:solidFill>
-                            <a:srgbClr val="16181D"/>
-                          </a:solidFill>
-                          <a:latin typeface="Arial" pitchFamily="34" charset="0"/>
-                          <a:ea typeface="Arial" pitchFamily="34" charset="-122"/>
-                          <a:cs typeface="Arial" pitchFamily="34" charset="-120"/>
-                        </a:rPr>
-                        <a:t>1.13 ms</a:t>
-                      </a:r>
-                      <a:endParaRPr lang="en-US" sz="1050" dirty="0">
-                        <a:latin typeface="Arial" charset="0"/>
-                        <a:ea typeface="Arial" charset="0"/>
-                        <a:cs typeface="Arial" charset="0"/>
-                      </a:endParaRPr>
-                    </a:p>
-                  </a:txBody>
-                  <a:tcPr marL="91440" marR="91440" marT="45720" marB="45720" anchor="ctr">
-                    <a:lnL w="6350" cap="flat" cmpd="sng" algn="ctr">
-                      <a:solidFill>
-                        <a:srgbClr val="D6DAE0"/>
-                      </a:solidFill>
-                      <a:prstDash val="solid"/>
-                      <a:round/>
-                      <a:headEnd type="none" w="med" len="med"/>
-                      <a:tailEnd type="none" w="med" len="med"/>
-                    </a:lnL>
-                    <a:lnR w="6350" cap="flat" cmpd="sng" algn="ctr">
-                      <a:solidFill>
-                        <a:srgbClr val="D6DAE0"/>
-                      </a:solidFill>
-                      <a:prstDash val="solid"/>
-                      <a:round/>
-                      <a:headEnd type="none" w="med" len="med"/>
-                      <a:tailEnd type="none" w="med" len="med"/>
-                    </a:lnR>
-                    <a:lnT w="6350" cap="flat" cmpd="sng" algn="ctr">
-                      <a:solidFill>
-                        <a:srgbClr val="D6DAE0"/>
-                      </a:solidFill>
-                      <a:prstDash val="solid"/>
-                      <a:round/>
-                      <a:headEnd type="none" w="med" len="med"/>
-                      <a:tailEnd type="none" w="med" len="med"/>
-                    </a:lnT>
-                    <a:lnB w="6350" cap="flat" cmpd="sng" algn="ctr">
-                      <a:solidFill>
-                        <a:srgbClr val="D6DAE0"/>
-                      </a:solidFill>
-                      <a:prstDash val="solid"/>
-                      <a:round/>
-                      <a:headEnd type="none" w="med" len="med"/>
-                      <a:tailEnd type="none" w="med" len="med"/>
-                    </a:lnB>
-                  </a:tcPr>
-                </a:tc>
-              </a:tr>
-              <a:tr h="411480">
-                <a:tc>
-                  <a:txBody>
-                    <a:bodyPr/>
-                    <a:lstStyle/>
-                    <a:p>
-                      <a:pPr indent="0" marL="0">
-                        <a:buNone/>
-                      </a:pPr>
-                      <a:r>
-                        <a:rPr lang="en-US" sz="1050" b="1" dirty="0">
-                          <a:solidFill>
-                            <a:srgbClr val="16181D"/>
-                          </a:solidFill>
-                          <a:latin typeface="Arial" pitchFamily="34" charset="0"/>
-                          <a:ea typeface="Arial" pitchFamily="34" charset="-122"/>
-                          <a:cs typeface="Arial" pitchFamily="34" charset="-120"/>
-                        </a:rPr>
-                        <a:t>Face inference (UltraFace, single-thread WASM)</a:t>
+                        <a:t>Checksum-invalid lookalikes (order ids)</a:t>
                       </a:r>
                       <a:endParaRPr lang="en-US" sz="1050" dirty="0">
                         <a:latin typeface="Arial" charset="0"/>
@@ -8277,13 +10611,13 @@
                       <a:r>
                         <a:rPr lang="en-US" sz="1050" b="1" dirty="0">
                           <a:solidFill>
-                            <a:srgbClr val="16181D"/>
+                            <a:srgbClr val="3D5A3D"/>
                           </a:solidFill>
                           <a:latin typeface="Arial" pitchFamily="34" charset="0"/>
                           <a:ea typeface="Arial" pitchFamily="34" charset="-122"/>
                           <a:cs typeface="Arial" pitchFamily="34" charset="-120"/>
                         </a:rPr>
-                        <a:t>12.91 ms</a:t>
+                        <a:t>NOT masked</a:t>
                       </a:r>
                       <a:endParaRPr lang="en-US" sz="1050" dirty="0">
                         <a:latin typeface="Arial" charset="0"/>
@@ -8331,268 +10665,6 @@
                     </a:lnB>
                   </a:tcPr>
                 </a:tc>
-                <a:tc>
-                  <a:txBody>
-                    <a:bodyPr/>
-                    <a:lstStyle/>
-                    <a:p>
-                      <a:pPr indent="0" marL="0">
-                        <a:buNone/>
-                      </a:pPr>
-                      <a:r>
-                        <a:rPr lang="en-US" sz="1050" dirty="0">
-                          <a:solidFill>
-                            <a:srgbClr val="16181D"/>
-                          </a:solidFill>
-                          <a:latin typeface="Arial" pitchFamily="34" charset="0"/>
-                          <a:ea typeface="Arial" pitchFamily="34" charset="-122"/>
-                          <a:cs typeface="Arial" pitchFamily="34" charset="-120"/>
-                        </a:rPr>
-                        <a:t>13.22 ms</a:t>
-                      </a:r>
-                      <a:endParaRPr lang="en-US" sz="1050" dirty="0">
-                        <a:latin typeface="Arial" charset="0"/>
-                        <a:ea typeface="Arial" charset="0"/>
-                        <a:cs typeface="Arial" charset="0"/>
-                      </a:endParaRPr>
-                    </a:p>
-                  </a:txBody>
-                  <a:tcPr marL="91440" marR="91440" marT="45720" marB="45720" anchor="ctr">
-                    <a:lnL w="6350" cap="flat" cmpd="sng" algn="ctr">
-                      <a:solidFill>
-                        <a:srgbClr val="D6DAE0"/>
-                      </a:solidFill>
-                      <a:prstDash val="solid"/>
-                      <a:round/>
-                      <a:headEnd type="none" w="med" len="med"/>
-                      <a:tailEnd type="none" w="med" len="med"/>
-                    </a:lnL>
-                    <a:lnR w="6350" cap="flat" cmpd="sng" algn="ctr">
-                      <a:solidFill>
-                        <a:srgbClr val="D6DAE0"/>
-                      </a:solidFill>
-                      <a:prstDash val="solid"/>
-                      <a:round/>
-                      <a:headEnd type="none" w="med" len="med"/>
-                      <a:tailEnd type="none" w="med" len="med"/>
-                    </a:lnR>
-                    <a:lnT w="6350" cap="flat" cmpd="sng" algn="ctr">
-                      <a:solidFill>
-                        <a:srgbClr val="D6DAE0"/>
-                      </a:solidFill>
-                      <a:prstDash val="solid"/>
-                      <a:round/>
-                      <a:headEnd type="none" w="med" len="med"/>
-                      <a:tailEnd type="none" w="med" len="med"/>
-                    </a:lnT>
-                    <a:lnB w="6350" cap="flat" cmpd="sng" algn="ctr">
-                      <a:solidFill>
-                        <a:srgbClr val="D6DAE0"/>
-                      </a:solidFill>
-                      <a:prstDash val="solid"/>
-                      <a:round/>
-                      <a:headEnd type="none" w="med" len="med"/>
-                      <a:tailEnd type="none" w="med" len="med"/>
-                    </a:lnB>
-                  </a:tcPr>
-                </a:tc>
-              </a:tr>
-              <a:tr h="411480">
-                <a:tc>
-                  <a:txBody>
-                    <a:bodyPr/>
-                    <a:lstStyle/>
-                    <a:p>
-                      <a:pPr indent="0" marL="0">
-                        <a:buNone/>
-                      </a:pPr>
-                      <a:r>
-                        <a:rPr lang="en-US" sz="1050" dirty="0">
-                          <a:solidFill>
-                            <a:srgbClr val="16181D"/>
-                          </a:solidFill>
-                          <a:latin typeface="Arial" pitchFamily="34" charset="0"/>
-                          <a:ea typeface="Arial" pitchFamily="34" charset="-122"/>
-                          <a:cs typeface="Arial" pitchFamily="34" charset="-120"/>
-                        </a:rPr>
-                        <a:t>Face postprocess (filter + NMS)</a:t>
-                      </a:r>
-                      <a:endParaRPr lang="en-US" sz="1050" dirty="0">
-                        <a:latin typeface="Arial" charset="0"/>
-                        <a:ea typeface="Arial" charset="0"/>
-                        <a:cs typeface="Arial" charset="0"/>
-                      </a:endParaRPr>
-                    </a:p>
-                  </a:txBody>
-                  <a:tcPr marL="91440" marR="91440" marT="45720" marB="45720" anchor="ctr">
-                    <a:lnL w="6350" cap="flat" cmpd="sng" algn="ctr">
-                      <a:solidFill>
-                        <a:srgbClr val="D6DAE0"/>
-                      </a:solidFill>
-                      <a:prstDash val="solid"/>
-                      <a:round/>
-                      <a:headEnd type="none" w="med" len="med"/>
-                      <a:tailEnd type="none" w="med" len="med"/>
-                    </a:lnL>
-                    <a:lnR w="6350" cap="flat" cmpd="sng" algn="ctr">
-                      <a:solidFill>
-                        <a:srgbClr val="D6DAE0"/>
-                      </a:solidFill>
-                      <a:prstDash val="solid"/>
-                      <a:round/>
-                      <a:headEnd type="none" w="med" len="med"/>
-                      <a:tailEnd type="none" w="med" len="med"/>
-                    </a:lnR>
-                    <a:lnT w="6350" cap="flat" cmpd="sng" algn="ctr">
-                      <a:solidFill>
-                        <a:srgbClr val="D6DAE0"/>
-                      </a:solidFill>
-                      <a:prstDash val="solid"/>
-                      <a:round/>
-                      <a:headEnd type="none" w="med" len="med"/>
-                      <a:tailEnd type="none" w="med" len="med"/>
-                    </a:lnT>
-                    <a:lnB w="6350" cap="flat" cmpd="sng" algn="ctr">
-                      <a:solidFill>
-                        <a:srgbClr val="D6DAE0"/>
-                      </a:solidFill>
-                      <a:prstDash val="solid"/>
-                      <a:round/>
-                      <a:headEnd type="none" w="med" len="med"/>
-                      <a:tailEnd type="none" w="med" len="med"/>
-                    </a:lnB>
-                  </a:tcPr>
-                </a:tc>
-                <a:tc>
-                  <a:txBody>
-                    <a:bodyPr/>
-                    <a:lstStyle/>
-                    <a:p>
-                      <a:pPr indent="0" marL="0">
-                        <a:buNone/>
-                      </a:pPr>
-                      <a:r>
-                        <a:rPr lang="en-US" sz="1050" dirty="0">
-                          <a:solidFill>
-                            <a:srgbClr val="16181D"/>
-                          </a:solidFill>
-                          <a:latin typeface="Arial" pitchFamily="34" charset="0"/>
-                          <a:ea typeface="Arial" pitchFamily="34" charset="-122"/>
-                          <a:cs typeface="Arial" pitchFamily="34" charset="-120"/>
-                        </a:rPr>
-                        <a:t>0.01 ms</a:t>
-                      </a:r>
-                      <a:endParaRPr lang="en-US" sz="1050" dirty="0">
-                        <a:latin typeface="Arial" charset="0"/>
-                        <a:ea typeface="Arial" charset="0"/>
-                        <a:cs typeface="Arial" charset="0"/>
-                      </a:endParaRPr>
-                    </a:p>
-                  </a:txBody>
-                  <a:tcPr marL="91440" marR="91440" marT="45720" marB="45720" anchor="ctr">
-                    <a:lnL w="6350" cap="flat" cmpd="sng" algn="ctr">
-                      <a:solidFill>
-                        <a:srgbClr val="D6DAE0"/>
-                      </a:solidFill>
-                      <a:prstDash val="solid"/>
-                      <a:round/>
-                      <a:headEnd type="none" w="med" len="med"/>
-                      <a:tailEnd type="none" w="med" len="med"/>
-                    </a:lnL>
-                    <a:lnR w="6350" cap="flat" cmpd="sng" algn="ctr">
-                      <a:solidFill>
-                        <a:srgbClr val="D6DAE0"/>
-                      </a:solidFill>
-                      <a:prstDash val="solid"/>
-                      <a:round/>
-                      <a:headEnd type="none" w="med" len="med"/>
-                      <a:tailEnd type="none" w="med" len="med"/>
-                    </a:lnR>
-                    <a:lnT w="6350" cap="flat" cmpd="sng" algn="ctr">
-                      <a:solidFill>
-                        <a:srgbClr val="D6DAE0"/>
-                      </a:solidFill>
-                      <a:prstDash val="solid"/>
-                      <a:round/>
-                      <a:headEnd type="none" w="med" len="med"/>
-                      <a:tailEnd type="none" w="med" len="med"/>
-                    </a:lnT>
-                    <a:lnB w="6350" cap="flat" cmpd="sng" algn="ctr">
-                      <a:solidFill>
-                        <a:srgbClr val="D6DAE0"/>
-                      </a:solidFill>
-                      <a:prstDash val="solid"/>
-                      <a:round/>
-                      <a:headEnd type="none" w="med" len="med"/>
-                      <a:tailEnd type="none" w="med" len="med"/>
-                    </a:lnB>
-                  </a:tcPr>
-                </a:tc>
-                <a:tc>
-                  <a:txBody>
-                    <a:bodyPr/>
-                    <a:lstStyle/>
-                    <a:p>
-                      <a:pPr indent="0" marL="0">
-                        <a:buNone/>
-                      </a:pPr>
-                      <a:r>
-                        <a:rPr lang="en-US" sz="1050" dirty="0">
-                          <a:solidFill>
-                            <a:srgbClr val="16181D"/>
-                          </a:solidFill>
-                          <a:latin typeface="Arial" pitchFamily="34" charset="0"/>
-                          <a:ea typeface="Arial" pitchFamily="34" charset="-122"/>
-                          <a:cs typeface="Arial" pitchFamily="34" charset="-120"/>
-                        </a:rPr>
-                        <a:t>0.02 ms</a:t>
-                      </a:r>
-                      <a:endParaRPr lang="en-US" sz="1050" dirty="0">
-                        <a:latin typeface="Arial" charset="0"/>
-                        <a:ea typeface="Arial" charset="0"/>
-                        <a:cs typeface="Arial" charset="0"/>
-                      </a:endParaRPr>
-                    </a:p>
-                  </a:txBody>
-                  <a:tcPr marL="91440" marR="91440" marT="45720" marB="45720" anchor="ctr">
-                    <a:lnL w="6350" cap="flat" cmpd="sng" algn="ctr">
-                      <a:solidFill>
-                        <a:srgbClr val="D6DAE0"/>
-                      </a:solidFill>
-                      <a:prstDash val="solid"/>
-                      <a:round/>
-                      <a:headEnd type="none" w="med" len="med"/>
-                      <a:tailEnd type="none" w="med" len="med"/>
-                    </a:lnL>
-                    <a:lnR w="6350" cap="flat" cmpd="sng" algn="ctr">
-                      <a:solidFill>
-                        <a:srgbClr val="D6DAE0"/>
-                      </a:solidFill>
-                      <a:prstDash val="solid"/>
-                      <a:round/>
-                      <a:headEnd type="none" w="med" len="med"/>
-                      <a:tailEnd type="none" w="med" len="med"/>
-                    </a:lnR>
-                    <a:lnT w="6350" cap="flat" cmpd="sng" algn="ctr">
-                      <a:solidFill>
-                        <a:srgbClr val="D6DAE0"/>
-                      </a:solidFill>
-                      <a:prstDash val="solid"/>
-                      <a:round/>
-                      <a:headEnd type="none" w="med" len="med"/>
-                      <a:tailEnd type="none" w="med" len="med"/>
-                    </a:lnT>
-                    <a:lnB w="6350" cap="flat" cmpd="sng" algn="ctr">
-                      <a:solidFill>
-                        <a:srgbClr val="D6DAE0"/>
-                      </a:solidFill>
-                      <a:prstDash val="solid"/>
-                      <a:round/>
-                      <a:headEnd type="none" w="med" len="med"/>
-                      <a:tailEnd type="none" w="med" len="med"/>
-                    </a:lnB>
-                  </a:tcPr>
-                </a:tc>
               </a:tr>
             </a:tbl>
           </a:graphicData>
@@ -8600,39 +10672,14 @@
       </p:graphicFrame>
       <p:sp>
         <p:nvSpPr>
-          <p:cNvPr id="5" name="Shape 2"/>
+          <p:cNvPr id="9" name="Text 4"/>
           <p:cNvSpPr/>
           <p:nvPr/>
         </p:nvSpPr>
         <p:spPr>
           <a:xfrm>
-            <a:off x="8321040" y="1463040"/>
-            <a:ext cx="3383280" cy="2377440"/>
-          </a:xfrm>
-          <a:prstGeom prst="rect">
-            <a:avLst/>
-          </a:prstGeom>
-          <a:solidFill>
-            <a:srgbClr val="EEF3F8"/>
-          </a:solidFill>
-          <a:ln w="9525">
-            <a:solidFill>
-              <a:srgbClr val="D6DAE0"/>
-            </a:solidFill>
-            <a:prstDash val="solid"/>
-          </a:ln>
-        </p:spPr>
-      </p:sp>
-      <p:sp>
-        <p:nvSpPr>
-          <p:cNvPr id="6" name="Text 3"/>
-          <p:cNvSpPr/>
-          <p:nvPr/>
-        </p:nvSpPr>
-        <p:spPr>
-          <a:xfrm>
-            <a:off x="8503920" y="1645920"/>
-            <a:ext cx="3017520" cy="2103120"/>
+            <a:off x="6629400" y="5715000"/>
+            <a:ext cx="5029200" cy="914400"/>
           </a:xfrm>
           <a:prstGeom prst="rect">
             <a:avLst/>
@@ -8641,105 +10688,24 @@
           <a:ln/>
         </p:spPr>
         <p:txBody>
-          <a:bodyPr wrap="square" rtlCol="0" anchor="t"/>
+          <a:bodyPr wrap="square" rtlCol="0" anchor="ctr"/>
           <a:lstStyle/>
           <a:p>
             <a:pPr indent="0" marL="0">
               <a:buNone/>
             </a:pPr>
             <a:r>
-              <a:rPr lang="en-US" sz="4000" b="1" dirty="0">
-                <a:solidFill>
-                  <a:srgbClr val="1F4E79"/>
+              <a:rPr lang="en-US" sz="950" i="1" dirty="0">
+                <a:solidFill>
+                  <a:srgbClr val="5A6470"/>
                 </a:solidFill>
                 <a:latin typeface="Arial" pitchFamily="34" charset="0"/>
                 <a:ea typeface="Arial" pitchFamily="34" charset="-122"/>
                 <a:cs typeface="Arial" pitchFamily="34" charset="-120"/>
               </a:rPr>
-              <a:t>16.2 ms</a:t>
-            </a:r>
-            <a:endParaRPr lang="en-US" sz="4000" dirty="0"/>
-          </a:p>
-          <a:p>
-            <a:pPr indent="0" marL="0">
-              <a:buNone/>
-            </a:pPr>
-            <a:r>
-              <a:rPr lang="en-US" sz="1150" dirty="0">
-                <a:solidFill>
-                  <a:srgbClr val="16181D"/>
-                </a:solidFill>
-                <a:latin typeface="Arial" pitchFamily="34" charset="0"/>
-                <a:ea typeface="Arial" pitchFamily="34" charset="-122"/>
-                <a:cs typeface="Arial" pitchFamily="34" charset="-120"/>
-              </a:rPr>
-              <a:t>summed single-frame local p50, vs the 175 ms design budget. A 10x margin on the conservative WASM path; WebGPU is faster.</a:t>
-            </a:r>
-            <a:endParaRPr lang="en-US" sz="4000" dirty="0"/>
-          </a:p>
-        </p:txBody>
-      </p:sp>
-      <p:sp>
-        <p:nvSpPr>
-          <p:cNvPr id="7" name="Text 4"/>
-          <p:cNvSpPr/>
-          <p:nvPr/>
-        </p:nvSpPr>
-        <p:spPr>
-          <a:xfrm>
-            <a:off x="502920" y="4892040"/>
-            <a:ext cx="11155680" cy="1463040"/>
-          </a:xfrm>
-          <a:prstGeom prst="rect">
-            <a:avLst/>
-          </a:prstGeom>
-          <a:noFill/>
-          <a:ln/>
-        </p:spPr>
-        <p:txBody>
-          <a:bodyPr wrap="square" rtlCol="0" anchor="t"/>
-          <a:lstStyle/>
-          <a:p>
-            <a:pPr marL="152400" indent="-152400">
-              <a:lnSpc>
-                <a:spcPct val="118000"/>
-              </a:lnSpc>
-              <a:buSzPct val="100000"/>
-              <a:buChar char="•"/>
-            </a:pPr>
-            <a:r>
-              <a:rPr lang="en-US" sz="1200" b="1" dirty="0">
-                <a:solidFill>
-                  <a:srgbClr val="16181D"/>
-                </a:solidFill>
-                <a:latin typeface="Arial" pitchFamily="34" charset="0"/>
-                <a:ea typeface="Arial" pitchFamily="34" charset="-122"/>
-                <a:cs typeface="Arial" pitchFamily="34" charset="-120"/>
-              </a:rPr>
-              <a:t>End-to-end latency is dominated by the remote planner, exactly as designed: the privacy layer costs milliseconds. Dirty-region tiling skips the whole visual pipeline on unchanged frames.</a:t>
-            </a:r>
-            <a:endParaRPr lang="en-US" sz="1200" dirty="0"/>
-          </a:p>
-          <a:p>
-            <a:pPr marL="152400" indent="-152400">
-              <a:lnSpc>
-                <a:spcPct val="118000"/>
-              </a:lnSpc>
-              <a:buSzPct val="100000"/>
-              <a:buChar char="•"/>
-            </a:pPr>
-            <a:r>
-              <a:rPr lang="en-US" sz="1200" dirty="0">
-                <a:solidFill>
-                  <a:srgbClr val="16181D"/>
-                </a:solidFill>
-                <a:latin typeface="Arial" pitchFamily="34" charset="0"/>
-                <a:ea typeface="Arial" pitchFamily="34" charset="-122"/>
-                <a:cs typeface="Arial" pitchFamily="34" charset="-120"/>
-              </a:rPr>
-              <a:t>Reproduce on any machine: npm run bench:latency (writes machine context with the numbers).</a:t>
-            </a:r>
-            <a:endParaRPr lang="en-US" sz="1200" dirty="0"/>
+              <a:t>Suite footprint: 193 automated tests · model 1.27 MB, SHA-pinned (provenance is a test) · corpus: 12 slices, 35 annotated instances + declared negatives · numbers regenerate with npm run bench and npm run bench:latency</a:t>
+            </a:r>
+            <a:endParaRPr lang="en-US" sz="950" dirty="0"/>
           </a:p>
         </p:txBody>
       </p:sp>
@@ -11367,7 +13333,7 @@
                           <a:ea typeface="Arial" pitchFamily="34" charset="-122"/>
                           <a:cs typeface="Arial" pitchFamily="34" charset="-120"/>
                         </a:rPr>
-                        <a:t>16.2 ms local p50 vs 175 ms budget, measured and reproducible</a:t>
+                        <a:t>15.9 ms local p50 vs 175 ms budget, measured and reproducible</a:t>
                       </a:r>
                       <a:endParaRPr lang="en-US" sz="1050" dirty="0">
                         <a:latin typeface="Arial" charset="0"/>

</xml_diff>

<commit_message>
Refresh assets and counts after the phase-0-reform merge
Panel screenshots regenerated against the merged green UI, deck and
evidence kit updated to the post-merge 203 test count, both rebuilt.
</commit_message>
<xml_diff>
--- a/docs/Kavach-SIH2026-Deck.pptx
+++ b/docs/Kavach-SIH2026-Deck.pptx
@@ -3099,7 +3099,7 @@
                 <a:ea typeface="Arial" pitchFamily="34" charset="-122"/>
                 <a:cs typeface="Arial" pitchFamily="34" charset="-120"/>
               </a:rPr>
-              <a:t>Working prototype  |  github.com/BhoomiAgrawal12/browser-vision-agent  |  194 automated tests</a:t>
+              <a:t>Working prototype  |  github.com/BhoomiAgrawal12/browser-vision-agent  |  203 automated tests</a:t>
             </a:r>
             <a:endParaRPr lang="en-US" sz="1200" dirty="0"/>
           </a:p>
@@ -11227,7 +11227,7 @@
                 <a:ea typeface="Arial" pitchFamily="34" charset="-122"/>
                 <a:cs typeface="Arial" pitchFamily="34" charset="-120"/>
               </a:rPr>
-              <a:t>Suite footprint: 194 automated tests · model 1.27 MB, SHA-pinned (provenance is a test) · corpus: 18 captures, 55 annotated positives + adversarial lookalike negatives (unicode dashes, digit-spacing evasions, Hindi labels, table splits) · regenerate: npm run bench, npm run bench:latency</a:t>
+              <a:t>Suite footprint: 203 automated tests · model 1.27 MB, SHA-pinned (provenance is a test) · corpus: 18 captures, 55 annotated positives + adversarial lookalike negatives (unicode dashes, digit-spacing evasions, Hindi labels, table splits) · regenerate: npm run bench, npm run bench:latency</a:t>
             </a:r>
             <a:endParaRPr lang="en-US" sz="950" dirty="0"/>
           </a:p>
@@ -12626,7 +12626,7 @@
                 <a:ea typeface="Arial" pitchFamily="34" charset="-122"/>
                 <a:cs typeface="Arial" pitchFamily="34" charset="-120"/>
               </a:rPr>
-              <a:t>194 automated tests across schema, detectors, policy, vault, gate, fusion, perception, server, benchmark and red team.</a:t>
+              <a:t>203 automated tests across schema, detectors, policy, vault, gate, fusion, perception, server, benchmark and red team.</a:t>
             </a:r>
             <a:endParaRPr lang="en-US" sz="1350" dirty="0"/>
           </a:p>

</xml_diff>